<commit_message>
More exercises in part a exam practice
</commit_message>
<xml_diff>
--- a/slides/exam_part_a.pptx
+++ b/slides/exam_part_a.pptx
@@ -5,10 +5,13 @@
     <p:sldMasterId id="2147483648" r:id="rId1"/>
   </p:sldMasterIdLst>
   <p:sldIdLst>
-    <p:sldId id="256" r:id="rId2"/>
-    <p:sldId id="257" r:id="rId3"/>
-    <p:sldId id="258" r:id="rId4"/>
-    <p:sldId id="259" r:id="rId5"/>
+    <p:sldId id="260" r:id="rId2"/>
+    <p:sldId id="261" r:id="rId3"/>
+    <p:sldId id="256" r:id="rId4"/>
+    <p:sldId id="257" r:id="rId5"/>
+    <p:sldId id="258" r:id="rId6"/>
+    <p:sldId id="259" r:id="rId7"/>
+    <p:sldId id="262" r:id="rId8"/>
   </p:sldIdLst>
   <p:sldSz cx="12192000" cy="6858000"/>
   <p:notesSz cx="6858000" cy="9144000"/>
@@ -107,6 +110,11 @@
       </a:defRPr>
     </a:lvl9pPr>
   </p:defaultTextStyle>
+  <p:extLst>
+    <p:ext uri="{EFAFB233-063F-42B5-8137-9DF3F51BA10A}">
+      <p15:sldGuideLst xmlns:p15="http://schemas.microsoft.com/office/powerpoint/2012/main"/>
+    </p:ext>
+  </p:extLst>
 </p:presentation>
 </file>
 
@@ -3347,6 +3355,2678 @@
       </p:grpSpPr>
       <p:pic>
         <p:nvPicPr>
+          <p:cNvPr id="5" name="Picture 4">
+            <a:extLst>
+              <a:ext uri="{FF2B5EF4-FFF2-40B4-BE49-F238E27FC236}">
+                <a16:creationId xmlns:a16="http://schemas.microsoft.com/office/drawing/2014/main" id="{8C4DB81F-2E9E-D254-811B-1C435E5EC615}"/>
+              </a:ext>
+            </a:extLst>
+          </p:cNvPr>
+          <p:cNvPicPr>
+            <a:picLocks noChangeAspect="1"/>
+          </p:cNvPicPr>
+          <p:nvPr/>
+        </p:nvPicPr>
+        <p:blipFill>
+          <a:blip r:embed="rId2"/>
+          <a:stretch>
+            <a:fillRect/>
+          </a:stretch>
+        </p:blipFill>
+        <p:spPr>
+          <a:xfrm>
+            <a:off x="419351" y="225175"/>
+            <a:ext cx="4982270" cy="2724530"/>
+          </a:xfrm>
+          <a:prstGeom prst="rect">
+            <a:avLst/>
+          </a:prstGeom>
+        </p:spPr>
+      </p:pic>
+      <p:pic>
+        <p:nvPicPr>
+          <p:cNvPr id="7" name="Picture 6">
+            <a:extLst>
+              <a:ext uri="{FF2B5EF4-FFF2-40B4-BE49-F238E27FC236}">
+                <a16:creationId xmlns:a16="http://schemas.microsoft.com/office/drawing/2014/main" id="{68862E22-F2BF-7B1C-722E-336097617A9E}"/>
+              </a:ext>
+            </a:extLst>
+          </p:cNvPr>
+          <p:cNvPicPr>
+            <a:picLocks noChangeAspect="1"/>
+          </p:cNvPicPr>
+          <p:nvPr/>
+        </p:nvPicPr>
+        <p:blipFill>
+          <a:blip r:embed="rId3"/>
+          <a:stretch>
+            <a:fillRect/>
+          </a:stretch>
+        </p:blipFill>
+        <p:spPr>
+          <a:xfrm>
+            <a:off x="3302251" y="1701208"/>
+            <a:ext cx="8570772" cy="3553447"/>
+          </a:xfrm>
+          <a:prstGeom prst="rect">
+            <a:avLst/>
+          </a:prstGeom>
+        </p:spPr>
+      </p:pic>
+      <p:grpSp>
+        <p:nvGrpSpPr>
+          <p:cNvPr id="8" name="Group 7">
+            <a:extLst>
+              <a:ext uri="{FF2B5EF4-FFF2-40B4-BE49-F238E27FC236}">
+                <a16:creationId xmlns:a16="http://schemas.microsoft.com/office/drawing/2014/main" id="{ADB537B2-A4A5-FACD-94DA-9F493F376749}"/>
+              </a:ext>
+            </a:extLst>
+          </p:cNvPr>
+          <p:cNvGrpSpPr/>
+          <p:nvPr/>
+        </p:nvGrpSpPr>
+        <p:grpSpPr>
+          <a:xfrm>
+            <a:off x="5646975" y="2361758"/>
+            <a:ext cx="1489570" cy="280156"/>
+            <a:chOff x="4648477" y="1042224"/>
+            <a:chExt cx="1222410" cy="280156"/>
+          </a:xfrm>
+        </p:grpSpPr>
+        <p:sp>
+          <p:nvSpPr>
+            <p:cNvPr id="9" name="Rectangle 8">
+              <a:extLst>
+                <a:ext uri="{FF2B5EF4-FFF2-40B4-BE49-F238E27FC236}">
+                  <a16:creationId xmlns:a16="http://schemas.microsoft.com/office/drawing/2014/main" id="{4CC9DE95-8276-5DCC-240C-BEBA55975C71}"/>
+                </a:ext>
+              </a:extLst>
+            </p:cNvPr>
+            <p:cNvSpPr/>
+            <p:nvPr/>
+          </p:nvSpPr>
+          <p:spPr>
+            <a:xfrm>
+              <a:off x="4648477" y="1042224"/>
+              <a:ext cx="1139811" cy="144603"/>
+            </a:xfrm>
+            <a:prstGeom prst="rect">
+              <a:avLst/>
+            </a:prstGeom>
+            <a:noFill/>
+            <a:ln>
+              <a:solidFill>
+                <a:srgbClr val="C00000"/>
+              </a:solidFill>
+            </a:ln>
+          </p:spPr>
+          <p:style>
+            <a:lnRef idx="2">
+              <a:schemeClr val="accent1">
+                <a:shade val="15000"/>
+              </a:schemeClr>
+            </a:lnRef>
+            <a:fillRef idx="1">
+              <a:schemeClr val="accent1"/>
+            </a:fillRef>
+            <a:effectRef idx="0">
+              <a:schemeClr val="accent1"/>
+            </a:effectRef>
+            <a:fontRef idx="minor">
+              <a:schemeClr val="lt1"/>
+            </a:fontRef>
+          </p:style>
+          <p:txBody>
+            <a:bodyPr rtlCol="0" anchor="ctr"/>
+            <a:lstStyle/>
+            <a:p>
+              <a:pPr algn="ctr"/>
+              <a:endParaRPr lang="LID4096"/>
+            </a:p>
+          </p:txBody>
+        </p:sp>
+        <p:sp>
+          <p:nvSpPr>
+            <p:cNvPr id="10" name="TextBox 9">
+              <a:extLst>
+                <a:ext uri="{FF2B5EF4-FFF2-40B4-BE49-F238E27FC236}">
+                  <a16:creationId xmlns:a16="http://schemas.microsoft.com/office/drawing/2014/main" id="{61D894EA-22D2-8D34-9AC2-AEA33035F2F0}"/>
+                </a:ext>
+              </a:extLst>
+            </p:cNvPr>
+            <p:cNvSpPr txBox="1"/>
+            <p:nvPr/>
+          </p:nvSpPr>
+          <p:spPr>
+            <a:xfrm>
+              <a:off x="5308905" y="1137714"/>
+              <a:ext cx="561982" cy="184666"/>
+            </a:xfrm>
+            <a:prstGeom prst="rect">
+              <a:avLst/>
+            </a:prstGeom>
+            <a:noFill/>
+          </p:spPr>
+          <p:txBody>
+            <a:bodyPr wrap="none" rtlCol="0">
+              <a:spAutoFit/>
+            </a:bodyPr>
+            <a:lstStyle/>
+            <a:p>
+              <a:pPr algn="r"/>
+              <a:r>
+                <a:rPr lang="sv-SE" sz="600">
+                  <a:solidFill>
+                    <a:srgbClr val="C00000"/>
+                  </a:solidFill>
+                </a:rPr>
+                <a:t>no initialization</a:t>
+              </a:r>
+              <a:endParaRPr lang="LID4096" sz="600">
+                <a:solidFill>
+                  <a:srgbClr val="C00000"/>
+                </a:solidFill>
+              </a:endParaRPr>
+            </a:p>
+          </p:txBody>
+        </p:sp>
+      </p:grpSp>
+      <p:grpSp>
+        <p:nvGrpSpPr>
+          <p:cNvPr id="11" name="Group 10">
+            <a:extLst>
+              <a:ext uri="{FF2B5EF4-FFF2-40B4-BE49-F238E27FC236}">
+                <a16:creationId xmlns:a16="http://schemas.microsoft.com/office/drawing/2014/main" id="{10427F0D-D20A-44EE-5CB2-8744D99B1000}"/>
+              </a:ext>
+            </a:extLst>
+          </p:cNvPr>
+          <p:cNvGrpSpPr/>
+          <p:nvPr/>
+        </p:nvGrpSpPr>
+        <p:grpSpPr>
+          <a:xfrm>
+            <a:off x="7741985" y="3055734"/>
+            <a:ext cx="1489570" cy="280156"/>
+            <a:chOff x="4648477" y="1042224"/>
+            <a:chExt cx="1222410" cy="280156"/>
+          </a:xfrm>
+        </p:grpSpPr>
+        <p:sp>
+          <p:nvSpPr>
+            <p:cNvPr id="12" name="Rectangle 11">
+              <a:extLst>
+                <a:ext uri="{FF2B5EF4-FFF2-40B4-BE49-F238E27FC236}">
+                  <a16:creationId xmlns:a16="http://schemas.microsoft.com/office/drawing/2014/main" id="{813DC75B-3AF6-8A80-302C-F9A8DCA7FBE9}"/>
+                </a:ext>
+              </a:extLst>
+            </p:cNvPr>
+            <p:cNvSpPr/>
+            <p:nvPr/>
+          </p:nvSpPr>
+          <p:spPr>
+            <a:xfrm>
+              <a:off x="4648477" y="1042224"/>
+              <a:ext cx="1139811" cy="144603"/>
+            </a:xfrm>
+            <a:prstGeom prst="rect">
+              <a:avLst/>
+            </a:prstGeom>
+            <a:noFill/>
+            <a:ln>
+              <a:solidFill>
+                <a:srgbClr val="C00000"/>
+              </a:solidFill>
+            </a:ln>
+          </p:spPr>
+          <p:style>
+            <a:lnRef idx="2">
+              <a:schemeClr val="accent1">
+                <a:shade val="15000"/>
+              </a:schemeClr>
+            </a:lnRef>
+            <a:fillRef idx="1">
+              <a:schemeClr val="accent1"/>
+            </a:fillRef>
+            <a:effectRef idx="0">
+              <a:schemeClr val="accent1"/>
+            </a:effectRef>
+            <a:fontRef idx="minor">
+              <a:schemeClr val="lt1"/>
+            </a:fontRef>
+          </p:style>
+          <p:txBody>
+            <a:bodyPr rtlCol="0" anchor="ctr"/>
+            <a:lstStyle/>
+            <a:p>
+              <a:pPr algn="ctr"/>
+              <a:endParaRPr lang="LID4096"/>
+            </a:p>
+          </p:txBody>
+        </p:sp>
+        <p:sp>
+          <p:nvSpPr>
+            <p:cNvPr id="13" name="TextBox 12">
+              <a:extLst>
+                <a:ext uri="{FF2B5EF4-FFF2-40B4-BE49-F238E27FC236}">
+                  <a16:creationId xmlns:a16="http://schemas.microsoft.com/office/drawing/2014/main" id="{DCAD9ADA-771F-3E7D-ADAA-B72BF3635680}"/>
+                </a:ext>
+              </a:extLst>
+            </p:cNvPr>
+            <p:cNvSpPr txBox="1"/>
+            <p:nvPr/>
+          </p:nvSpPr>
+          <p:spPr>
+            <a:xfrm>
+              <a:off x="5236553" y="1137714"/>
+              <a:ext cx="634334" cy="184666"/>
+            </a:xfrm>
+            <a:prstGeom prst="rect">
+              <a:avLst/>
+            </a:prstGeom>
+            <a:noFill/>
+          </p:spPr>
+          <p:txBody>
+            <a:bodyPr wrap="none" rtlCol="0">
+              <a:spAutoFit/>
+            </a:bodyPr>
+            <a:lstStyle/>
+            <a:p>
+              <a:pPr algn="r"/>
+              <a:r>
+                <a:rPr lang="sv-SE" sz="600">
+                  <a:solidFill>
+                    <a:srgbClr val="C00000"/>
+                  </a:solidFill>
+                </a:rPr>
+                <a:t>not enough space</a:t>
+              </a:r>
+              <a:endParaRPr lang="LID4096" sz="600">
+                <a:solidFill>
+                  <a:srgbClr val="C00000"/>
+                </a:solidFill>
+              </a:endParaRPr>
+            </a:p>
+          </p:txBody>
+        </p:sp>
+      </p:grpSp>
+      <p:grpSp>
+        <p:nvGrpSpPr>
+          <p:cNvPr id="14" name="Group 13">
+            <a:extLst>
+              <a:ext uri="{FF2B5EF4-FFF2-40B4-BE49-F238E27FC236}">
+                <a16:creationId xmlns:a16="http://schemas.microsoft.com/office/drawing/2014/main" id="{45E4085D-7D86-5BA9-7E7E-1266D74C8008}"/>
+              </a:ext>
+            </a:extLst>
+          </p:cNvPr>
+          <p:cNvGrpSpPr/>
+          <p:nvPr/>
+        </p:nvGrpSpPr>
+        <p:grpSpPr>
+          <a:xfrm>
+            <a:off x="9841355" y="2775578"/>
+            <a:ext cx="1489570" cy="280156"/>
+            <a:chOff x="4648477" y="1042224"/>
+            <a:chExt cx="1222410" cy="280156"/>
+          </a:xfrm>
+        </p:grpSpPr>
+        <p:sp>
+          <p:nvSpPr>
+            <p:cNvPr id="15" name="Rectangle 14">
+              <a:extLst>
+                <a:ext uri="{FF2B5EF4-FFF2-40B4-BE49-F238E27FC236}">
+                  <a16:creationId xmlns:a16="http://schemas.microsoft.com/office/drawing/2014/main" id="{E32FA9EC-68D3-9914-35F6-97EBCBCABAC0}"/>
+                </a:ext>
+              </a:extLst>
+            </p:cNvPr>
+            <p:cNvSpPr/>
+            <p:nvPr/>
+          </p:nvSpPr>
+          <p:spPr>
+            <a:xfrm>
+              <a:off x="4648477" y="1042224"/>
+              <a:ext cx="1139811" cy="144603"/>
+            </a:xfrm>
+            <a:prstGeom prst="rect">
+              <a:avLst/>
+            </a:prstGeom>
+            <a:noFill/>
+            <a:ln>
+              <a:solidFill>
+                <a:srgbClr val="C00000"/>
+              </a:solidFill>
+            </a:ln>
+          </p:spPr>
+          <p:style>
+            <a:lnRef idx="2">
+              <a:schemeClr val="accent1">
+                <a:shade val="15000"/>
+              </a:schemeClr>
+            </a:lnRef>
+            <a:fillRef idx="1">
+              <a:schemeClr val="accent1"/>
+            </a:fillRef>
+            <a:effectRef idx="0">
+              <a:schemeClr val="accent1"/>
+            </a:effectRef>
+            <a:fontRef idx="minor">
+              <a:schemeClr val="lt1"/>
+            </a:fontRef>
+          </p:style>
+          <p:txBody>
+            <a:bodyPr rtlCol="0" anchor="ctr"/>
+            <a:lstStyle/>
+            <a:p>
+              <a:pPr algn="ctr"/>
+              <a:endParaRPr lang="LID4096"/>
+            </a:p>
+          </p:txBody>
+        </p:sp>
+        <p:sp>
+          <p:nvSpPr>
+            <p:cNvPr id="16" name="TextBox 15">
+              <a:extLst>
+                <a:ext uri="{FF2B5EF4-FFF2-40B4-BE49-F238E27FC236}">
+                  <a16:creationId xmlns:a16="http://schemas.microsoft.com/office/drawing/2014/main" id="{6DCF2ACD-0A28-EFD9-2405-8DBA897E16C8}"/>
+                </a:ext>
+              </a:extLst>
+            </p:cNvPr>
+            <p:cNvSpPr txBox="1"/>
+            <p:nvPr/>
+          </p:nvSpPr>
+          <p:spPr>
+            <a:xfrm>
+              <a:off x="5372049" y="1137714"/>
+              <a:ext cx="498838" cy="184666"/>
+            </a:xfrm>
+            <a:prstGeom prst="rect">
+              <a:avLst/>
+            </a:prstGeom>
+            <a:noFill/>
+          </p:spPr>
+          <p:txBody>
+            <a:bodyPr wrap="none" rtlCol="0">
+              <a:spAutoFit/>
+            </a:bodyPr>
+            <a:lstStyle/>
+            <a:p>
+              <a:pPr algn="r"/>
+              <a:r>
+                <a:rPr lang="sv-SE" sz="600">
+                  <a:solidFill>
+                    <a:srgbClr val="C00000"/>
+                  </a:solidFill>
+                </a:rPr>
+                <a:t>initialization</a:t>
+              </a:r>
+              <a:endParaRPr lang="LID4096" sz="600">
+                <a:solidFill>
+                  <a:srgbClr val="C00000"/>
+                </a:solidFill>
+              </a:endParaRPr>
+            </a:p>
+          </p:txBody>
+        </p:sp>
+      </p:grpSp>
+      <p:grpSp>
+        <p:nvGrpSpPr>
+          <p:cNvPr id="17" name="Group 16">
+            <a:extLst>
+              <a:ext uri="{FF2B5EF4-FFF2-40B4-BE49-F238E27FC236}">
+                <a16:creationId xmlns:a16="http://schemas.microsoft.com/office/drawing/2014/main" id="{31A7088B-DCAE-1139-079D-35FF09FC3169}"/>
+              </a:ext>
+            </a:extLst>
+          </p:cNvPr>
+          <p:cNvGrpSpPr/>
+          <p:nvPr/>
+        </p:nvGrpSpPr>
+        <p:grpSpPr>
+          <a:xfrm>
+            <a:off x="3517160" y="4352299"/>
+            <a:ext cx="1489570" cy="280156"/>
+            <a:chOff x="4648477" y="1042224"/>
+            <a:chExt cx="1222410" cy="280156"/>
+          </a:xfrm>
+        </p:grpSpPr>
+        <p:sp>
+          <p:nvSpPr>
+            <p:cNvPr id="18" name="Rectangle 17">
+              <a:extLst>
+                <a:ext uri="{FF2B5EF4-FFF2-40B4-BE49-F238E27FC236}">
+                  <a16:creationId xmlns:a16="http://schemas.microsoft.com/office/drawing/2014/main" id="{991520AE-B892-39C9-58B8-A9B240DB3828}"/>
+                </a:ext>
+              </a:extLst>
+            </p:cNvPr>
+            <p:cNvSpPr/>
+            <p:nvPr/>
+          </p:nvSpPr>
+          <p:spPr>
+            <a:xfrm>
+              <a:off x="4648477" y="1042224"/>
+              <a:ext cx="1139811" cy="144603"/>
+            </a:xfrm>
+            <a:prstGeom prst="rect">
+              <a:avLst/>
+            </a:prstGeom>
+            <a:noFill/>
+            <a:ln>
+              <a:solidFill>
+                <a:srgbClr val="C00000"/>
+              </a:solidFill>
+            </a:ln>
+          </p:spPr>
+          <p:style>
+            <a:lnRef idx="2">
+              <a:schemeClr val="accent1">
+                <a:shade val="15000"/>
+              </a:schemeClr>
+            </a:lnRef>
+            <a:fillRef idx="1">
+              <a:schemeClr val="accent1"/>
+            </a:fillRef>
+            <a:effectRef idx="0">
+              <a:schemeClr val="accent1"/>
+            </a:effectRef>
+            <a:fontRef idx="minor">
+              <a:schemeClr val="lt1"/>
+            </a:fontRef>
+          </p:style>
+          <p:txBody>
+            <a:bodyPr rtlCol="0" anchor="ctr"/>
+            <a:lstStyle/>
+            <a:p>
+              <a:pPr algn="ctr"/>
+              <a:endParaRPr lang="LID4096"/>
+            </a:p>
+          </p:txBody>
+        </p:sp>
+        <p:sp>
+          <p:nvSpPr>
+            <p:cNvPr id="19" name="TextBox 18">
+              <a:extLst>
+                <a:ext uri="{FF2B5EF4-FFF2-40B4-BE49-F238E27FC236}">
+                  <a16:creationId xmlns:a16="http://schemas.microsoft.com/office/drawing/2014/main" id="{4365B49E-D6CC-10D9-F6C9-C32D38E903FC}"/>
+                </a:ext>
+              </a:extLst>
+            </p:cNvPr>
+            <p:cNvSpPr txBox="1"/>
+            <p:nvPr/>
+          </p:nvSpPr>
+          <p:spPr>
+            <a:xfrm>
+              <a:off x="5508862" y="1137714"/>
+              <a:ext cx="362025" cy="184666"/>
+            </a:xfrm>
+            <a:prstGeom prst="rect">
+              <a:avLst/>
+            </a:prstGeom>
+            <a:noFill/>
+          </p:spPr>
+          <p:txBody>
+            <a:bodyPr wrap="none" rtlCol="0">
+              <a:spAutoFit/>
+            </a:bodyPr>
+            <a:lstStyle/>
+            <a:p>
+              <a:pPr algn="r"/>
+              <a:r>
+                <a:rPr lang="sv-SE" sz="600">
+                  <a:solidFill>
+                    <a:srgbClr val="C00000"/>
+                  </a:solidFill>
+                </a:rPr>
+                <a:t>no align</a:t>
+              </a:r>
+              <a:endParaRPr lang="LID4096" sz="600">
+                <a:solidFill>
+                  <a:srgbClr val="C00000"/>
+                </a:solidFill>
+              </a:endParaRPr>
+            </a:p>
+          </p:txBody>
+        </p:sp>
+      </p:grpSp>
+      <p:grpSp>
+        <p:nvGrpSpPr>
+          <p:cNvPr id="20" name="Group 19">
+            <a:extLst>
+              <a:ext uri="{FF2B5EF4-FFF2-40B4-BE49-F238E27FC236}">
+                <a16:creationId xmlns:a16="http://schemas.microsoft.com/office/drawing/2014/main" id="{06FB155F-55F3-18C5-A0FF-A65062358AC5}"/>
+              </a:ext>
+            </a:extLst>
+          </p:cNvPr>
+          <p:cNvGrpSpPr/>
+          <p:nvPr/>
+        </p:nvGrpSpPr>
+        <p:grpSpPr>
+          <a:xfrm>
+            <a:off x="5650401" y="4259966"/>
+            <a:ext cx="1458635" cy="464823"/>
+            <a:chOff x="4648477" y="1042224"/>
+            <a:chExt cx="1197023" cy="206731"/>
+          </a:xfrm>
+        </p:grpSpPr>
+        <p:sp>
+          <p:nvSpPr>
+            <p:cNvPr id="21" name="Rectangle 20">
+              <a:extLst>
+                <a:ext uri="{FF2B5EF4-FFF2-40B4-BE49-F238E27FC236}">
+                  <a16:creationId xmlns:a16="http://schemas.microsoft.com/office/drawing/2014/main" id="{FE61105C-74C9-5B38-A318-5A8886601175}"/>
+                </a:ext>
+              </a:extLst>
+            </p:cNvPr>
+            <p:cNvSpPr/>
+            <p:nvPr/>
+          </p:nvSpPr>
+          <p:spPr>
+            <a:xfrm>
+              <a:off x="4648477" y="1042224"/>
+              <a:ext cx="1139811" cy="144603"/>
+            </a:xfrm>
+            <a:prstGeom prst="rect">
+              <a:avLst/>
+            </a:prstGeom>
+            <a:noFill/>
+            <a:ln>
+              <a:solidFill>
+                <a:srgbClr val="C00000"/>
+              </a:solidFill>
+            </a:ln>
+          </p:spPr>
+          <p:style>
+            <a:lnRef idx="2">
+              <a:schemeClr val="accent1">
+                <a:shade val="15000"/>
+              </a:schemeClr>
+            </a:lnRef>
+            <a:fillRef idx="1">
+              <a:schemeClr val="accent1"/>
+            </a:fillRef>
+            <a:effectRef idx="0">
+              <a:schemeClr val="accent1"/>
+            </a:effectRef>
+            <a:fontRef idx="minor">
+              <a:schemeClr val="lt1"/>
+            </a:fontRef>
+          </p:style>
+          <p:txBody>
+            <a:bodyPr rtlCol="0" anchor="ctr"/>
+            <a:lstStyle/>
+            <a:p>
+              <a:pPr algn="ctr"/>
+              <a:endParaRPr lang="LID4096"/>
+            </a:p>
+          </p:txBody>
+        </p:sp>
+        <p:sp>
+          <p:nvSpPr>
+            <p:cNvPr id="22" name="TextBox 21">
+              <a:extLst>
+                <a:ext uri="{FF2B5EF4-FFF2-40B4-BE49-F238E27FC236}">
+                  <a16:creationId xmlns:a16="http://schemas.microsoft.com/office/drawing/2014/main" id="{6068714B-DA17-12A9-4331-F96123599D2F}"/>
+                </a:ext>
+              </a:extLst>
+            </p:cNvPr>
+            <p:cNvSpPr txBox="1"/>
+            <p:nvPr/>
+          </p:nvSpPr>
+          <p:spPr>
+            <a:xfrm>
+              <a:off x="5187487" y="1166824"/>
+              <a:ext cx="658013" cy="82131"/>
+            </a:xfrm>
+            <a:prstGeom prst="rect">
+              <a:avLst/>
+            </a:prstGeom>
+            <a:noFill/>
+          </p:spPr>
+          <p:txBody>
+            <a:bodyPr wrap="none" rtlCol="0">
+              <a:spAutoFit/>
+            </a:bodyPr>
+            <a:lstStyle/>
+            <a:p>
+              <a:pPr algn="r"/>
+              <a:r>
+                <a:rPr lang="sv-SE" sz="600">
+                  <a:solidFill>
+                    <a:srgbClr val="C00000"/>
+                  </a:solidFill>
+                </a:rPr>
+                <a:t>no init and no align</a:t>
+              </a:r>
+              <a:endParaRPr lang="LID4096" sz="600">
+                <a:solidFill>
+                  <a:srgbClr val="C00000"/>
+                </a:solidFill>
+              </a:endParaRPr>
+            </a:p>
+          </p:txBody>
+        </p:sp>
+      </p:grpSp>
+      <p:grpSp>
+        <p:nvGrpSpPr>
+          <p:cNvPr id="26" name="Group 25">
+            <a:extLst>
+              <a:ext uri="{FF2B5EF4-FFF2-40B4-BE49-F238E27FC236}">
+                <a16:creationId xmlns:a16="http://schemas.microsoft.com/office/drawing/2014/main" id="{D9673456-9294-92DD-0A63-DD786F879B84}"/>
+              </a:ext>
+            </a:extLst>
+          </p:cNvPr>
+          <p:cNvGrpSpPr/>
+          <p:nvPr/>
+        </p:nvGrpSpPr>
+        <p:grpSpPr>
+          <a:xfrm>
+            <a:off x="9887156" y="4142375"/>
+            <a:ext cx="1486890" cy="619108"/>
+            <a:chOff x="4648477" y="1042224"/>
+            <a:chExt cx="1170632" cy="206069"/>
+          </a:xfrm>
+        </p:grpSpPr>
+        <p:sp>
+          <p:nvSpPr>
+            <p:cNvPr id="27" name="Rectangle 26">
+              <a:extLst>
+                <a:ext uri="{FF2B5EF4-FFF2-40B4-BE49-F238E27FC236}">
+                  <a16:creationId xmlns:a16="http://schemas.microsoft.com/office/drawing/2014/main" id="{C2D50A70-B4BB-9910-4761-16440F335D7C}"/>
+                </a:ext>
+              </a:extLst>
+            </p:cNvPr>
+            <p:cNvSpPr/>
+            <p:nvPr/>
+          </p:nvSpPr>
+          <p:spPr>
+            <a:xfrm>
+              <a:off x="4648477" y="1042224"/>
+              <a:ext cx="1139811" cy="144603"/>
+            </a:xfrm>
+            <a:prstGeom prst="rect">
+              <a:avLst/>
+            </a:prstGeom>
+            <a:noFill/>
+            <a:ln>
+              <a:solidFill>
+                <a:srgbClr val="C00000"/>
+              </a:solidFill>
+            </a:ln>
+          </p:spPr>
+          <p:style>
+            <a:lnRef idx="2">
+              <a:schemeClr val="accent1">
+                <a:shade val="15000"/>
+              </a:schemeClr>
+            </a:lnRef>
+            <a:fillRef idx="1">
+              <a:schemeClr val="accent1"/>
+            </a:fillRef>
+            <a:effectRef idx="0">
+              <a:schemeClr val="accent1"/>
+            </a:effectRef>
+            <a:fontRef idx="minor">
+              <a:schemeClr val="lt1"/>
+            </a:fontRef>
+          </p:style>
+          <p:txBody>
+            <a:bodyPr rtlCol="0" anchor="ctr"/>
+            <a:lstStyle/>
+            <a:p>
+              <a:pPr algn="ctr"/>
+              <a:endParaRPr lang="LID4096"/>
+            </a:p>
+          </p:txBody>
+        </p:sp>
+        <p:sp>
+          <p:nvSpPr>
+            <p:cNvPr id="28" name="TextBox 27">
+              <a:extLst>
+                <a:ext uri="{FF2B5EF4-FFF2-40B4-BE49-F238E27FC236}">
+                  <a16:creationId xmlns:a16="http://schemas.microsoft.com/office/drawing/2014/main" id="{084D3331-FACD-3D78-FC06-FDCA92AAFF79}"/>
+                </a:ext>
+              </a:extLst>
+            </p:cNvPr>
+            <p:cNvSpPr txBox="1"/>
+            <p:nvPr/>
+          </p:nvSpPr>
+          <p:spPr>
+            <a:xfrm>
+              <a:off x="5103275" y="1186827"/>
+              <a:ext cx="715834" cy="61466"/>
+            </a:xfrm>
+            <a:prstGeom prst="rect">
+              <a:avLst/>
+            </a:prstGeom>
+            <a:noFill/>
+          </p:spPr>
+          <p:txBody>
+            <a:bodyPr wrap="none" rtlCol="0">
+              <a:spAutoFit/>
+            </a:bodyPr>
+            <a:lstStyle/>
+            <a:p>
+              <a:pPr algn="r"/>
+              <a:r>
+                <a:rPr lang="sv-SE" sz="600">
+                  <a:solidFill>
+                    <a:srgbClr val="C00000"/>
+                  </a:solidFill>
+                </a:rPr>
+                <a:t>no init x 2 and no align</a:t>
+              </a:r>
+              <a:endParaRPr lang="LID4096" sz="600">
+                <a:solidFill>
+                  <a:srgbClr val="C00000"/>
+                </a:solidFill>
+              </a:endParaRPr>
+            </a:p>
+          </p:txBody>
+        </p:sp>
+      </p:grpSp>
+      <p:grpSp>
+        <p:nvGrpSpPr>
+          <p:cNvPr id="29" name="Group 28">
+            <a:extLst>
+              <a:ext uri="{FF2B5EF4-FFF2-40B4-BE49-F238E27FC236}">
+                <a16:creationId xmlns:a16="http://schemas.microsoft.com/office/drawing/2014/main" id="{1CF5BE28-F03E-3F80-28FE-AA74D818A250}"/>
+              </a:ext>
+            </a:extLst>
+          </p:cNvPr>
+          <p:cNvGrpSpPr/>
+          <p:nvPr/>
+        </p:nvGrpSpPr>
+        <p:grpSpPr>
+          <a:xfrm>
+            <a:off x="3520721" y="2640025"/>
+            <a:ext cx="1489570" cy="280156"/>
+            <a:chOff x="4648477" y="1042224"/>
+            <a:chExt cx="1222410" cy="280156"/>
+          </a:xfrm>
+        </p:grpSpPr>
+        <p:sp>
+          <p:nvSpPr>
+            <p:cNvPr id="30" name="Rectangle 29">
+              <a:extLst>
+                <a:ext uri="{FF2B5EF4-FFF2-40B4-BE49-F238E27FC236}">
+                  <a16:creationId xmlns:a16="http://schemas.microsoft.com/office/drawing/2014/main" id="{161033F4-C000-5A7E-C160-12CD8BFCA91C}"/>
+                </a:ext>
+              </a:extLst>
+            </p:cNvPr>
+            <p:cNvSpPr/>
+            <p:nvPr/>
+          </p:nvSpPr>
+          <p:spPr>
+            <a:xfrm>
+              <a:off x="4648477" y="1042224"/>
+              <a:ext cx="1139811" cy="144603"/>
+            </a:xfrm>
+            <a:prstGeom prst="rect">
+              <a:avLst/>
+            </a:prstGeom>
+            <a:noFill/>
+            <a:ln>
+              <a:solidFill>
+                <a:srgbClr val="C00000"/>
+              </a:solidFill>
+            </a:ln>
+          </p:spPr>
+          <p:style>
+            <a:lnRef idx="2">
+              <a:schemeClr val="accent1">
+                <a:shade val="15000"/>
+              </a:schemeClr>
+            </a:lnRef>
+            <a:fillRef idx="1">
+              <a:schemeClr val="accent1"/>
+            </a:fillRef>
+            <a:effectRef idx="0">
+              <a:schemeClr val="accent1"/>
+            </a:effectRef>
+            <a:fontRef idx="minor">
+              <a:schemeClr val="lt1"/>
+            </a:fontRef>
+          </p:style>
+          <p:txBody>
+            <a:bodyPr rtlCol="0" anchor="ctr"/>
+            <a:lstStyle/>
+            <a:p>
+              <a:pPr algn="ctr"/>
+              <a:endParaRPr lang="LID4096"/>
+            </a:p>
+          </p:txBody>
+        </p:sp>
+        <p:sp>
+          <p:nvSpPr>
+            <p:cNvPr id="31" name="TextBox 30">
+              <a:extLst>
+                <a:ext uri="{FF2B5EF4-FFF2-40B4-BE49-F238E27FC236}">
+                  <a16:creationId xmlns:a16="http://schemas.microsoft.com/office/drawing/2014/main" id="{025FA6E7-59BD-48D9-CF89-29D27B64921D}"/>
+                </a:ext>
+              </a:extLst>
+            </p:cNvPr>
+            <p:cNvSpPr txBox="1"/>
+            <p:nvPr/>
+          </p:nvSpPr>
+          <p:spPr>
+            <a:xfrm>
+              <a:off x="5508862" y="1137714"/>
+              <a:ext cx="362025" cy="184666"/>
+            </a:xfrm>
+            <a:prstGeom prst="rect">
+              <a:avLst/>
+            </a:prstGeom>
+            <a:noFill/>
+          </p:spPr>
+          <p:txBody>
+            <a:bodyPr wrap="none" rtlCol="0">
+              <a:spAutoFit/>
+            </a:bodyPr>
+            <a:lstStyle/>
+            <a:p>
+              <a:pPr algn="r"/>
+              <a:r>
+                <a:rPr lang="sv-SE" sz="600">
+                  <a:solidFill>
+                    <a:srgbClr val="C00000"/>
+                  </a:solidFill>
+                </a:rPr>
+                <a:t>no align</a:t>
+              </a:r>
+              <a:endParaRPr lang="LID4096" sz="600">
+                <a:solidFill>
+                  <a:srgbClr val="C00000"/>
+                </a:solidFill>
+              </a:endParaRPr>
+            </a:p>
+          </p:txBody>
+        </p:sp>
+      </p:grpSp>
+    </p:spTree>
+    <p:extLst>
+      <p:ext uri="{BB962C8B-B14F-4D97-AF65-F5344CB8AC3E}">
+        <p14:creationId xmlns:p14="http://schemas.microsoft.com/office/powerpoint/2010/main" val="1004228950"/>
+      </p:ext>
+    </p:extLst>
+  </p:cSld>
+  <p:clrMapOvr>
+    <a:masterClrMapping/>
+  </p:clrMapOvr>
+  <p:timing>
+    <p:tnLst>
+      <p:par>
+        <p:cTn id="1" dur="indefinite" restart="never" nodeType="tmRoot">
+          <p:childTnLst>
+            <p:seq concurrent="1" nextAc="seek">
+              <p:cTn id="2" dur="indefinite" nodeType="mainSeq">
+                <p:childTnLst>
+                  <p:par>
+                    <p:cTn id="3" fill="hold">
+                      <p:stCondLst>
+                        <p:cond delay="indefinite"/>
+                      </p:stCondLst>
+                      <p:childTnLst>
+                        <p:par>
+                          <p:cTn id="4" fill="hold">
+                            <p:stCondLst>
+                              <p:cond delay="0"/>
+                            </p:stCondLst>
+                            <p:childTnLst>
+                              <p:par>
+                                <p:cTn id="5" presetID="10" presetClass="entr" presetSubtype="0" fill="hold" nodeType="clickEffect">
+                                  <p:stCondLst>
+                                    <p:cond delay="0"/>
+                                  </p:stCondLst>
+                                  <p:childTnLst>
+                                    <p:set>
+                                      <p:cBhvr>
+                                        <p:cTn id="6" dur="1" fill="hold">
+                                          <p:stCondLst>
+                                            <p:cond delay="0"/>
+                                          </p:stCondLst>
+                                        </p:cTn>
+                                        <p:tgtEl>
+                                          <p:spTgt spid="8"/>
+                                        </p:tgtEl>
+                                        <p:attrNameLst>
+                                          <p:attrName>style.visibility</p:attrName>
+                                        </p:attrNameLst>
+                                      </p:cBhvr>
+                                      <p:to>
+                                        <p:strVal val="visible"/>
+                                      </p:to>
+                                    </p:set>
+                                    <p:animEffect transition="in" filter="fade">
+                                      <p:cBhvr>
+                                        <p:cTn id="7" dur="500"/>
+                                        <p:tgtEl>
+                                          <p:spTgt spid="8"/>
+                                        </p:tgtEl>
+                                      </p:cBhvr>
+                                    </p:animEffect>
+                                  </p:childTnLst>
+                                </p:cTn>
+                              </p:par>
+                            </p:childTnLst>
+                          </p:cTn>
+                        </p:par>
+                      </p:childTnLst>
+                    </p:cTn>
+                  </p:par>
+                  <p:par>
+                    <p:cTn id="8" fill="hold">
+                      <p:stCondLst>
+                        <p:cond delay="indefinite"/>
+                      </p:stCondLst>
+                      <p:childTnLst>
+                        <p:par>
+                          <p:cTn id="9" fill="hold">
+                            <p:stCondLst>
+                              <p:cond delay="0"/>
+                            </p:stCondLst>
+                            <p:childTnLst>
+                              <p:par>
+                                <p:cTn id="10" presetID="10" presetClass="entr" presetSubtype="0" fill="hold" nodeType="clickEffect">
+                                  <p:stCondLst>
+                                    <p:cond delay="0"/>
+                                  </p:stCondLst>
+                                  <p:childTnLst>
+                                    <p:set>
+                                      <p:cBhvr>
+                                        <p:cTn id="11" dur="1" fill="hold">
+                                          <p:stCondLst>
+                                            <p:cond delay="0"/>
+                                          </p:stCondLst>
+                                        </p:cTn>
+                                        <p:tgtEl>
+                                          <p:spTgt spid="11"/>
+                                        </p:tgtEl>
+                                        <p:attrNameLst>
+                                          <p:attrName>style.visibility</p:attrName>
+                                        </p:attrNameLst>
+                                      </p:cBhvr>
+                                      <p:to>
+                                        <p:strVal val="visible"/>
+                                      </p:to>
+                                    </p:set>
+                                    <p:animEffect transition="in" filter="fade">
+                                      <p:cBhvr>
+                                        <p:cTn id="12" dur="500"/>
+                                        <p:tgtEl>
+                                          <p:spTgt spid="11"/>
+                                        </p:tgtEl>
+                                      </p:cBhvr>
+                                    </p:animEffect>
+                                  </p:childTnLst>
+                                </p:cTn>
+                              </p:par>
+                            </p:childTnLst>
+                          </p:cTn>
+                        </p:par>
+                      </p:childTnLst>
+                    </p:cTn>
+                  </p:par>
+                  <p:par>
+                    <p:cTn id="13" fill="hold">
+                      <p:stCondLst>
+                        <p:cond delay="indefinite"/>
+                      </p:stCondLst>
+                      <p:childTnLst>
+                        <p:par>
+                          <p:cTn id="14" fill="hold">
+                            <p:stCondLst>
+                              <p:cond delay="0"/>
+                            </p:stCondLst>
+                            <p:childTnLst>
+                              <p:par>
+                                <p:cTn id="15" presetID="10" presetClass="entr" presetSubtype="0" fill="hold" nodeType="clickEffect">
+                                  <p:stCondLst>
+                                    <p:cond delay="0"/>
+                                  </p:stCondLst>
+                                  <p:childTnLst>
+                                    <p:set>
+                                      <p:cBhvr>
+                                        <p:cTn id="16" dur="1" fill="hold">
+                                          <p:stCondLst>
+                                            <p:cond delay="0"/>
+                                          </p:stCondLst>
+                                        </p:cTn>
+                                        <p:tgtEl>
+                                          <p:spTgt spid="14"/>
+                                        </p:tgtEl>
+                                        <p:attrNameLst>
+                                          <p:attrName>style.visibility</p:attrName>
+                                        </p:attrNameLst>
+                                      </p:cBhvr>
+                                      <p:to>
+                                        <p:strVal val="visible"/>
+                                      </p:to>
+                                    </p:set>
+                                    <p:animEffect transition="in" filter="fade">
+                                      <p:cBhvr>
+                                        <p:cTn id="17" dur="500"/>
+                                        <p:tgtEl>
+                                          <p:spTgt spid="14"/>
+                                        </p:tgtEl>
+                                      </p:cBhvr>
+                                    </p:animEffect>
+                                  </p:childTnLst>
+                                </p:cTn>
+                              </p:par>
+                            </p:childTnLst>
+                          </p:cTn>
+                        </p:par>
+                      </p:childTnLst>
+                    </p:cTn>
+                  </p:par>
+                  <p:par>
+                    <p:cTn id="18" fill="hold">
+                      <p:stCondLst>
+                        <p:cond delay="indefinite"/>
+                      </p:stCondLst>
+                      <p:childTnLst>
+                        <p:par>
+                          <p:cTn id="19" fill="hold">
+                            <p:stCondLst>
+                              <p:cond delay="0"/>
+                            </p:stCondLst>
+                            <p:childTnLst>
+                              <p:par>
+                                <p:cTn id="20" presetID="10" presetClass="entr" presetSubtype="0" fill="hold" nodeType="clickEffect">
+                                  <p:stCondLst>
+                                    <p:cond delay="0"/>
+                                  </p:stCondLst>
+                                  <p:childTnLst>
+                                    <p:set>
+                                      <p:cBhvr>
+                                        <p:cTn id="21" dur="1" fill="hold">
+                                          <p:stCondLst>
+                                            <p:cond delay="0"/>
+                                          </p:stCondLst>
+                                        </p:cTn>
+                                        <p:tgtEl>
+                                          <p:spTgt spid="17"/>
+                                        </p:tgtEl>
+                                        <p:attrNameLst>
+                                          <p:attrName>style.visibility</p:attrName>
+                                        </p:attrNameLst>
+                                      </p:cBhvr>
+                                      <p:to>
+                                        <p:strVal val="visible"/>
+                                      </p:to>
+                                    </p:set>
+                                    <p:animEffect transition="in" filter="fade">
+                                      <p:cBhvr>
+                                        <p:cTn id="22" dur="500"/>
+                                        <p:tgtEl>
+                                          <p:spTgt spid="17"/>
+                                        </p:tgtEl>
+                                      </p:cBhvr>
+                                    </p:animEffect>
+                                  </p:childTnLst>
+                                </p:cTn>
+                              </p:par>
+                            </p:childTnLst>
+                          </p:cTn>
+                        </p:par>
+                      </p:childTnLst>
+                    </p:cTn>
+                  </p:par>
+                  <p:par>
+                    <p:cTn id="23" fill="hold">
+                      <p:stCondLst>
+                        <p:cond delay="indefinite"/>
+                      </p:stCondLst>
+                      <p:childTnLst>
+                        <p:par>
+                          <p:cTn id="24" fill="hold">
+                            <p:stCondLst>
+                              <p:cond delay="0"/>
+                            </p:stCondLst>
+                            <p:childTnLst>
+                              <p:par>
+                                <p:cTn id="25" presetID="10" presetClass="entr" presetSubtype="0" fill="hold" nodeType="clickEffect">
+                                  <p:stCondLst>
+                                    <p:cond delay="0"/>
+                                  </p:stCondLst>
+                                  <p:childTnLst>
+                                    <p:set>
+                                      <p:cBhvr>
+                                        <p:cTn id="26" dur="1" fill="hold">
+                                          <p:stCondLst>
+                                            <p:cond delay="0"/>
+                                          </p:stCondLst>
+                                        </p:cTn>
+                                        <p:tgtEl>
+                                          <p:spTgt spid="20"/>
+                                        </p:tgtEl>
+                                        <p:attrNameLst>
+                                          <p:attrName>style.visibility</p:attrName>
+                                        </p:attrNameLst>
+                                      </p:cBhvr>
+                                      <p:to>
+                                        <p:strVal val="visible"/>
+                                      </p:to>
+                                    </p:set>
+                                    <p:animEffect transition="in" filter="fade">
+                                      <p:cBhvr>
+                                        <p:cTn id="27" dur="500"/>
+                                        <p:tgtEl>
+                                          <p:spTgt spid="20"/>
+                                        </p:tgtEl>
+                                      </p:cBhvr>
+                                    </p:animEffect>
+                                  </p:childTnLst>
+                                </p:cTn>
+                              </p:par>
+                            </p:childTnLst>
+                          </p:cTn>
+                        </p:par>
+                      </p:childTnLst>
+                    </p:cTn>
+                  </p:par>
+                  <p:par>
+                    <p:cTn id="28" fill="hold">
+                      <p:stCondLst>
+                        <p:cond delay="indefinite"/>
+                      </p:stCondLst>
+                      <p:childTnLst>
+                        <p:par>
+                          <p:cTn id="29" fill="hold">
+                            <p:stCondLst>
+                              <p:cond delay="0"/>
+                            </p:stCondLst>
+                            <p:childTnLst>
+                              <p:par>
+                                <p:cTn id="30" presetID="10" presetClass="entr" presetSubtype="0" fill="hold" nodeType="clickEffect">
+                                  <p:stCondLst>
+                                    <p:cond delay="0"/>
+                                  </p:stCondLst>
+                                  <p:childTnLst>
+                                    <p:set>
+                                      <p:cBhvr>
+                                        <p:cTn id="31" dur="1" fill="hold">
+                                          <p:stCondLst>
+                                            <p:cond delay="0"/>
+                                          </p:stCondLst>
+                                        </p:cTn>
+                                        <p:tgtEl>
+                                          <p:spTgt spid="26"/>
+                                        </p:tgtEl>
+                                        <p:attrNameLst>
+                                          <p:attrName>style.visibility</p:attrName>
+                                        </p:attrNameLst>
+                                      </p:cBhvr>
+                                      <p:to>
+                                        <p:strVal val="visible"/>
+                                      </p:to>
+                                    </p:set>
+                                    <p:animEffect transition="in" filter="fade">
+                                      <p:cBhvr>
+                                        <p:cTn id="32" dur="500"/>
+                                        <p:tgtEl>
+                                          <p:spTgt spid="26"/>
+                                        </p:tgtEl>
+                                      </p:cBhvr>
+                                    </p:animEffect>
+                                  </p:childTnLst>
+                                </p:cTn>
+                              </p:par>
+                            </p:childTnLst>
+                          </p:cTn>
+                        </p:par>
+                      </p:childTnLst>
+                    </p:cTn>
+                  </p:par>
+                  <p:par>
+                    <p:cTn id="33" fill="hold">
+                      <p:stCondLst>
+                        <p:cond delay="indefinite"/>
+                      </p:stCondLst>
+                      <p:childTnLst>
+                        <p:par>
+                          <p:cTn id="34" fill="hold">
+                            <p:stCondLst>
+                              <p:cond delay="0"/>
+                            </p:stCondLst>
+                            <p:childTnLst>
+                              <p:par>
+                                <p:cTn id="35" presetID="10" presetClass="entr" presetSubtype="0" fill="hold" nodeType="clickEffect">
+                                  <p:stCondLst>
+                                    <p:cond delay="0"/>
+                                  </p:stCondLst>
+                                  <p:childTnLst>
+                                    <p:set>
+                                      <p:cBhvr>
+                                        <p:cTn id="36" dur="1" fill="hold">
+                                          <p:stCondLst>
+                                            <p:cond delay="0"/>
+                                          </p:stCondLst>
+                                        </p:cTn>
+                                        <p:tgtEl>
+                                          <p:spTgt spid="29"/>
+                                        </p:tgtEl>
+                                        <p:attrNameLst>
+                                          <p:attrName>style.visibility</p:attrName>
+                                        </p:attrNameLst>
+                                      </p:cBhvr>
+                                      <p:to>
+                                        <p:strVal val="visible"/>
+                                      </p:to>
+                                    </p:set>
+                                    <p:animEffect transition="in" filter="fade">
+                                      <p:cBhvr>
+                                        <p:cTn id="37" dur="500"/>
+                                        <p:tgtEl>
+                                          <p:spTgt spid="29"/>
+                                        </p:tgtEl>
+                                      </p:cBhvr>
+                                    </p:animEffect>
+                                  </p:childTnLst>
+                                </p:cTn>
+                              </p:par>
+                            </p:childTnLst>
+                          </p:cTn>
+                        </p:par>
+                      </p:childTnLst>
+                    </p:cTn>
+                  </p:par>
+                </p:childTnLst>
+              </p:cTn>
+              <p:prevCondLst>
+                <p:cond evt="onPrev" delay="0">
+                  <p:tgtEl>
+                    <p:sldTgt/>
+                  </p:tgtEl>
+                </p:cond>
+              </p:prevCondLst>
+              <p:nextCondLst>
+                <p:cond evt="onNext" delay="0">
+                  <p:tgtEl>
+                    <p:sldTgt/>
+                  </p:tgtEl>
+                </p:cond>
+              </p:nextCondLst>
+            </p:seq>
+          </p:childTnLst>
+        </p:cTn>
+      </p:par>
+    </p:tnLst>
+  </p:timing>
+</p:sld>
+</file>
+
+<file path=ppt/slides/slide2.xml><?xml version="1.0" encoding="utf-8"?>
+<p:sld xmlns:a="http://schemas.openxmlformats.org/drawingml/2006/main" xmlns:r="http://schemas.openxmlformats.org/officeDocument/2006/relationships" xmlns:p="http://schemas.openxmlformats.org/presentationml/2006/main">
+  <p:cSld>
+    <p:spTree>
+      <p:nvGrpSpPr>
+        <p:cNvPr id="1" name=""/>
+        <p:cNvGrpSpPr/>
+        <p:nvPr/>
+      </p:nvGrpSpPr>
+      <p:grpSpPr>
+        <a:xfrm>
+          <a:off x="0" y="0"/>
+          <a:ext cx="0" cy="0"/>
+          <a:chOff x="0" y="0"/>
+          <a:chExt cx="0" cy="0"/>
+        </a:xfrm>
+      </p:grpSpPr>
+      <p:pic>
+        <p:nvPicPr>
+          <p:cNvPr id="5" name="Picture 4">
+            <a:extLst>
+              <a:ext uri="{FF2B5EF4-FFF2-40B4-BE49-F238E27FC236}">
+                <a16:creationId xmlns:a16="http://schemas.microsoft.com/office/drawing/2014/main" id="{21AE7397-1330-846D-605A-DDA6823BC3E7}"/>
+              </a:ext>
+            </a:extLst>
+          </p:cNvPr>
+          <p:cNvPicPr>
+            <a:picLocks noChangeAspect="1"/>
+          </p:cNvPicPr>
+          <p:nvPr/>
+        </p:nvPicPr>
+        <p:blipFill>
+          <a:blip r:embed="rId2"/>
+          <a:stretch>
+            <a:fillRect/>
+          </a:stretch>
+        </p:blipFill>
+        <p:spPr>
+          <a:xfrm>
+            <a:off x="164912" y="0"/>
+            <a:ext cx="5414281" cy="1963938"/>
+          </a:xfrm>
+          <a:prstGeom prst="rect">
+            <a:avLst/>
+          </a:prstGeom>
+        </p:spPr>
+      </p:pic>
+      <p:pic>
+        <p:nvPicPr>
+          <p:cNvPr id="7" name="Picture 6">
+            <a:extLst>
+              <a:ext uri="{FF2B5EF4-FFF2-40B4-BE49-F238E27FC236}">
+                <a16:creationId xmlns:a16="http://schemas.microsoft.com/office/drawing/2014/main" id="{A3DC76BA-76A3-449F-21F8-BEB7F5FE4B54}"/>
+              </a:ext>
+            </a:extLst>
+          </p:cNvPr>
+          <p:cNvPicPr>
+            <a:picLocks noChangeAspect="1"/>
+          </p:cNvPicPr>
+          <p:nvPr/>
+        </p:nvPicPr>
+        <p:blipFill>
+          <a:blip r:embed="rId3"/>
+          <a:stretch>
+            <a:fillRect/>
+          </a:stretch>
+        </p:blipFill>
+        <p:spPr>
+          <a:xfrm>
+            <a:off x="2467095" y="1450281"/>
+            <a:ext cx="9724905" cy="5302661"/>
+          </a:xfrm>
+          <a:prstGeom prst="rect">
+            <a:avLst/>
+          </a:prstGeom>
+        </p:spPr>
+      </p:pic>
+      <p:pic>
+        <p:nvPicPr>
+          <p:cNvPr id="9" name="Picture 8">
+            <a:extLst>
+              <a:ext uri="{FF2B5EF4-FFF2-40B4-BE49-F238E27FC236}">
+                <a16:creationId xmlns:a16="http://schemas.microsoft.com/office/drawing/2014/main" id="{2EC013D4-3B57-1C26-5B85-4F3C49E650E6}"/>
+              </a:ext>
+            </a:extLst>
+          </p:cNvPr>
+          <p:cNvPicPr>
+            <a:picLocks noChangeAspect="1"/>
+          </p:cNvPicPr>
+          <p:nvPr/>
+        </p:nvPicPr>
+        <p:blipFill>
+          <a:blip r:embed="rId4"/>
+          <a:stretch>
+            <a:fillRect/>
+          </a:stretch>
+        </p:blipFill>
+        <p:spPr>
+          <a:xfrm>
+            <a:off x="106160" y="1928896"/>
+            <a:ext cx="2419688" cy="1009791"/>
+          </a:xfrm>
+          <a:prstGeom prst="rect">
+            <a:avLst/>
+          </a:prstGeom>
+        </p:spPr>
+      </p:pic>
+      <p:grpSp>
+        <p:nvGrpSpPr>
+          <p:cNvPr id="10" name="Group 9">
+            <a:extLst>
+              <a:ext uri="{FF2B5EF4-FFF2-40B4-BE49-F238E27FC236}">
+                <a16:creationId xmlns:a16="http://schemas.microsoft.com/office/drawing/2014/main" id="{36F715AE-1DAB-F389-9F8A-3AE6AB19679B}"/>
+              </a:ext>
+            </a:extLst>
+          </p:cNvPr>
+          <p:cNvGrpSpPr/>
+          <p:nvPr/>
+        </p:nvGrpSpPr>
+        <p:grpSpPr>
+          <a:xfrm>
+            <a:off x="2772189" y="3665004"/>
+            <a:ext cx="1489570" cy="280156"/>
+            <a:chOff x="4648477" y="1042224"/>
+            <a:chExt cx="1222410" cy="280156"/>
+          </a:xfrm>
+        </p:grpSpPr>
+        <p:sp>
+          <p:nvSpPr>
+            <p:cNvPr id="11" name="Rectangle 10">
+              <a:extLst>
+                <a:ext uri="{FF2B5EF4-FFF2-40B4-BE49-F238E27FC236}">
+                  <a16:creationId xmlns:a16="http://schemas.microsoft.com/office/drawing/2014/main" id="{D965CB79-4CCA-AEEE-DCE4-AFFFDC7BFB93}"/>
+                </a:ext>
+              </a:extLst>
+            </p:cNvPr>
+            <p:cNvSpPr/>
+            <p:nvPr/>
+          </p:nvSpPr>
+          <p:spPr>
+            <a:xfrm>
+              <a:off x="4648477" y="1042224"/>
+              <a:ext cx="1139811" cy="144603"/>
+            </a:xfrm>
+            <a:prstGeom prst="rect">
+              <a:avLst/>
+            </a:prstGeom>
+            <a:noFill/>
+            <a:ln>
+              <a:solidFill>
+                <a:srgbClr val="C00000"/>
+              </a:solidFill>
+            </a:ln>
+          </p:spPr>
+          <p:style>
+            <a:lnRef idx="2">
+              <a:schemeClr val="accent1">
+                <a:shade val="15000"/>
+              </a:schemeClr>
+            </a:lnRef>
+            <a:fillRef idx="1">
+              <a:schemeClr val="accent1"/>
+            </a:fillRef>
+            <a:effectRef idx="0">
+              <a:schemeClr val="accent1"/>
+            </a:effectRef>
+            <a:fontRef idx="minor">
+              <a:schemeClr val="lt1"/>
+            </a:fontRef>
+          </p:style>
+          <p:txBody>
+            <a:bodyPr rtlCol="0" anchor="ctr"/>
+            <a:lstStyle/>
+            <a:p>
+              <a:pPr algn="ctr"/>
+              <a:endParaRPr lang="LID4096"/>
+            </a:p>
+          </p:txBody>
+        </p:sp>
+        <p:sp>
+          <p:nvSpPr>
+            <p:cNvPr id="12" name="TextBox 11">
+              <a:extLst>
+                <a:ext uri="{FF2B5EF4-FFF2-40B4-BE49-F238E27FC236}">
+                  <a16:creationId xmlns:a16="http://schemas.microsoft.com/office/drawing/2014/main" id="{6BD84A51-2F1C-A1E2-314D-61CBF5364873}"/>
+                </a:ext>
+              </a:extLst>
+            </p:cNvPr>
+            <p:cNvSpPr txBox="1"/>
+            <p:nvPr/>
+          </p:nvSpPr>
+          <p:spPr>
+            <a:xfrm>
+              <a:off x="5543065" y="1137714"/>
+              <a:ext cx="327822" cy="184666"/>
+            </a:xfrm>
+            <a:prstGeom prst="rect">
+              <a:avLst/>
+            </a:prstGeom>
+            <a:noFill/>
+          </p:spPr>
+          <p:txBody>
+            <a:bodyPr wrap="none" rtlCol="0">
+              <a:spAutoFit/>
+            </a:bodyPr>
+            <a:lstStyle/>
+            <a:p>
+              <a:pPr algn="r"/>
+              <a:r>
+                <a:rPr lang="sv-SE" sz="600">
+                  <a:solidFill>
+                    <a:srgbClr val="C00000"/>
+                  </a:solidFill>
+                </a:rPr>
+                <a:t>d is int</a:t>
+              </a:r>
+              <a:endParaRPr lang="LID4096" sz="600">
+                <a:solidFill>
+                  <a:srgbClr val="C00000"/>
+                </a:solidFill>
+              </a:endParaRPr>
+            </a:p>
+          </p:txBody>
+        </p:sp>
+      </p:grpSp>
+      <p:grpSp>
+        <p:nvGrpSpPr>
+          <p:cNvPr id="13" name="Group 12">
+            <a:extLst>
+              <a:ext uri="{FF2B5EF4-FFF2-40B4-BE49-F238E27FC236}">
+                <a16:creationId xmlns:a16="http://schemas.microsoft.com/office/drawing/2014/main" id="{1AC333E8-9CF9-E2B9-CC0D-CF846D45E741}"/>
+              </a:ext>
+            </a:extLst>
+          </p:cNvPr>
+          <p:cNvGrpSpPr/>
+          <p:nvPr/>
+        </p:nvGrpSpPr>
+        <p:grpSpPr>
+          <a:xfrm>
+            <a:off x="5204702" y="2867684"/>
+            <a:ext cx="1489570" cy="280156"/>
+            <a:chOff x="4648477" y="1042224"/>
+            <a:chExt cx="1222410" cy="280156"/>
+          </a:xfrm>
+        </p:grpSpPr>
+        <p:sp>
+          <p:nvSpPr>
+            <p:cNvPr id="14" name="Rectangle 13">
+              <a:extLst>
+                <a:ext uri="{FF2B5EF4-FFF2-40B4-BE49-F238E27FC236}">
+                  <a16:creationId xmlns:a16="http://schemas.microsoft.com/office/drawing/2014/main" id="{2043DA8C-8A62-A4C4-F0A1-B2C52395A305}"/>
+                </a:ext>
+              </a:extLst>
+            </p:cNvPr>
+            <p:cNvSpPr/>
+            <p:nvPr/>
+          </p:nvSpPr>
+          <p:spPr>
+            <a:xfrm>
+              <a:off x="4648477" y="1042224"/>
+              <a:ext cx="1139811" cy="144603"/>
+            </a:xfrm>
+            <a:prstGeom prst="rect">
+              <a:avLst/>
+            </a:prstGeom>
+            <a:noFill/>
+            <a:ln>
+              <a:solidFill>
+                <a:srgbClr val="C00000"/>
+              </a:solidFill>
+            </a:ln>
+          </p:spPr>
+          <p:style>
+            <a:lnRef idx="2">
+              <a:schemeClr val="accent1">
+                <a:shade val="15000"/>
+              </a:schemeClr>
+            </a:lnRef>
+            <a:fillRef idx="1">
+              <a:schemeClr val="accent1"/>
+            </a:fillRef>
+            <a:effectRef idx="0">
+              <a:schemeClr val="accent1"/>
+            </a:effectRef>
+            <a:fontRef idx="minor">
+              <a:schemeClr val="lt1"/>
+            </a:fontRef>
+          </p:style>
+          <p:txBody>
+            <a:bodyPr rtlCol="0" anchor="ctr"/>
+            <a:lstStyle/>
+            <a:p>
+              <a:pPr algn="ctr"/>
+              <a:endParaRPr lang="LID4096"/>
+            </a:p>
+          </p:txBody>
+        </p:sp>
+        <p:sp>
+          <p:nvSpPr>
+            <p:cNvPr id="15" name="TextBox 14">
+              <a:extLst>
+                <a:ext uri="{FF2B5EF4-FFF2-40B4-BE49-F238E27FC236}">
+                  <a16:creationId xmlns:a16="http://schemas.microsoft.com/office/drawing/2014/main" id="{B25BF8D6-791C-9E88-F705-A67ACEBBC14D}"/>
+                </a:ext>
+              </a:extLst>
+            </p:cNvPr>
+            <p:cNvSpPr txBox="1"/>
+            <p:nvPr/>
+          </p:nvSpPr>
+          <p:spPr>
+            <a:xfrm>
+              <a:off x="5623310" y="1137714"/>
+              <a:ext cx="247577" cy="184666"/>
+            </a:xfrm>
+            <a:prstGeom prst="rect">
+              <a:avLst/>
+            </a:prstGeom>
+            <a:noFill/>
+          </p:spPr>
+          <p:txBody>
+            <a:bodyPr wrap="none" rtlCol="0">
+              <a:spAutoFit/>
+            </a:bodyPr>
+            <a:lstStyle/>
+            <a:p>
+              <a:pPr algn="r"/>
+              <a:r>
+                <a:rPr lang="sv-SE" sz="600">
+                  <a:solidFill>
+                    <a:srgbClr val="C00000"/>
+                  </a:solidFill>
+                </a:rPr>
+                <a:t>x16</a:t>
+              </a:r>
+              <a:endParaRPr lang="LID4096" sz="600">
+                <a:solidFill>
+                  <a:srgbClr val="C00000"/>
+                </a:solidFill>
+              </a:endParaRPr>
+            </a:p>
+          </p:txBody>
+        </p:sp>
+      </p:grpSp>
+      <p:grpSp>
+        <p:nvGrpSpPr>
+          <p:cNvPr id="16" name="Group 15">
+            <a:extLst>
+              <a:ext uri="{FF2B5EF4-FFF2-40B4-BE49-F238E27FC236}">
+                <a16:creationId xmlns:a16="http://schemas.microsoft.com/office/drawing/2014/main" id="{8879B440-FB3F-3BFC-7421-28443A5D6F76}"/>
+              </a:ext>
+            </a:extLst>
+          </p:cNvPr>
+          <p:cNvGrpSpPr/>
+          <p:nvPr/>
+        </p:nvGrpSpPr>
+        <p:grpSpPr>
+          <a:xfrm>
+            <a:off x="10031139" y="2203795"/>
+            <a:ext cx="1489570" cy="280156"/>
+            <a:chOff x="4648477" y="1042224"/>
+            <a:chExt cx="1222410" cy="280156"/>
+          </a:xfrm>
+        </p:grpSpPr>
+        <p:sp>
+          <p:nvSpPr>
+            <p:cNvPr id="17" name="Rectangle 16">
+              <a:extLst>
+                <a:ext uri="{FF2B5EF4-FFF2-40B4-BE49-F238E27FC236}">
+                  <a16:creationId xmlns:a16="http://schemas.microsoft.com/office/drawing/2014/main" id="{EDEB43D0-16FD-3147-1914-1B6016AC374C}"/>
+                </a:ext>
+              </a:extLst>
+            </p:cNvPr>
+            <p:cNvSpPr/>
+            <p:nvPr/>
+          </p:nvSpPr>
+          <p:spPr>
+            <a:xfrm>
+              <a:off x="4648477" y="1042224"/>
+              <a:ext cx="1139811" cy="144603"/>
+            </a:xfrm>
+            <a:prstGeom prst="rect">
+              <a:avLst/>
+            </a:prstGeom>
+            <a:noFill/>
+            <a:ln>
+              <a:solidFill>
+                <a:srgbClr val="C00000"/>
+              </a:solidFill>
+            </a:ln>
+          </p:spPr>
+          <p:style>
+            <a:lnRef idx="2">
+              <a:schemeClr val="accent1">
+                <a:shade val="15000"/>
+              </a:schemeClr>
+            </a:lnRef>
+            <a:fillRef idx="1">
+              <a:schemeClr val="accent1"/>
+            </a:fillRef>
+            <a:effectRef idx="0">
+              <a:schemeClr val="accent1"/>
+            </a:effectRef>
+            <a:fontRef idx="minor">
+              <a:schemeClr val="lt1"/>
+            </a:fontRef>
+          </p:style>
+          <p:txBody>
+            <a:bodyPr rtlCol="0" anchor="ctr"/>
+            <a:lstStyle/>
+            <a:p>
+              <a:pPr algn="ctr"/>
+              <a:endParaRPr lang="LID4096"/>
+            </a:p>
+          </p:txBody>
+        </p:sp>
+        <p:sp>
+          <p:nvSpPr>
+            <p:cNvPr id="18" name="TextBox 17">
+              <a:extLst>
+                <a:ext uri="{FF2B5EF4-FFF2-40B4-BE49-F238E27FC236}">
+                  <a16:creationId xmlns:a16="http://schemas.microsoft.com/office/drawing/2014/main" id="{0716183C-8C66-5248-BA2D-AFA1EAF552F0}"/>
+                </a:ext>
+              </a:extLst>
+            </p:cNvPr>
+            <p:cNvSpPr txBox="1"/>
+            <p:nvPr/>
+          </p:nvSpPr>
+          <p:spPr>
+            <a:xfrm>
+              <a:off x="5440456" y="1137714"/>
+              <a:ext cx="430431" cy="184666"/>
+            </a:xfrm>
+            <a:prstGeom prst="rect">
+              <a:avLst/>
+            </a:prstGeom>
+            <a:noFill/>
+          </p:spPr>
+          <p:txBody>
+            <a:bodyPr wrap="none" rtlCol="0">
+              <a:spAutoFit/>
+            </a:bodyPr>
+            <a:lstStyle/>
+            <a:p>
+              <a:pPr algn="r"/>
+              <a:r>
+                <a:rPr lang="en-GB" sz="600">
+                  <a:solidFill>
+                    <a:srgbClr val="C00000"/>
+                  </a:solidFill>
+                </a:rPr>
+                <a:t>a is uint16</a:t>
+              </a:r>
+              <a:endParaRPr lang="LID4096" sz="600">
+                <a:solidFill>
+                  <a:srgbClr val="C00000"/>
+                </a:solidFill>
+              </a:endParaRPr>
+            </a:p>
+          </p:txBody>
+        </p:sp>
+      </p:grpSp>
+      <p:grpSp>
+        <p:nvGrpSpPr>
+          <p:cNvPr id="19" name="Group 18">
+            <a:extLst>
+              <a:ext uri="{FF2B5EF4-FFF2-40B4-BE49-F238E27FC236}">
+                <a16:creationId xmlns:a16="http://schemas.microsoft.com/office/drawing/2014/main" id="{DEB1A97E-5482-1415-F6A5-C902639A8238}"/>
+              </a:ext>
+            </a:extLst>
+          </p:cNvPr>
+          <p:cNvGrpSpPr/>
+          <p:nvPr/>
+        </p:nvGrpSpPr>
+        <p:grpSpPr>
+          <a:xfrm>
+            <a:off x="2772189" y="5801874"/>
+            <a:ext cx="1489570" cy="280156"/>
+            <a:chOff x="4648477" y="1042224"/>
+            <a:chExt cx="1222410" cy="280156"/>
+          </a:xfrm>
+        </p:grpSpPr>
+        <p:sp>
+          <p:nvSpPr>
+            <p:cNvPr id="20" name="Rectangle 19">
+              <a:extLst>
+                <a:ext uri="{FF2B5EF4-FFF2-40B4-BE49-F238E27FC236}">
+                  <a16:creationId xmlns:a16="http://schemas.microsoft.com/office/drawing/2014/main" id="{4015A185-D4C6-8435-245D-8C507A01E289}"/>
+                </a:ext>
+              </a:extLst>
+            </p:cNvPr>
+            <p:cNvSpPr/>
+            <p:nvPr/>
+          </p:nvSpPr>
+          <p:spPr>
+            <a:xfrm>
+              <a:off x="4648477" y="1042224"/>
+              <a:ext cx="1139811" cy="144603"/>
+            </a:xfrm>
+            <a:prstGeom prst="rect">
+              <a:avLst/>
+            </a:prstGeom>
+            <a:noFill/>
+            <a:ln>
+              <a:solidFill>
+                <a:srgbClr val="C00000"/>
+              </a:solidFill>
+            </a:ln>
+          </p:spPr>
+          <p:style>
+            <a:lnRef idx="2">
+              <a:schemeClr val="accent1">
+                <a:shade val="15000"/>
+              </a:schemeClr>
+            </a:lnRef>
+            <a:fillRef idx="1">
+              <a:schemeClr val="accent1"/>
+            </a:fillRef>
+            <a:effectRef idx="0">
+              <a:schemeClr val="accent1"/>
+            </a:effectRef>
+            <a:fontRef idx="minor">
+              <a:schemeClr val="lt1"/>
+            </a:fontRef>
+          </p:style>
+          <p:txBody>
+            <a:bodyPr rtlCol="0" anchor="ctr"/>
+            <a:lstStyle/>
+            <a:p>
+              <a:pPr algn="ctr"/>
+              <a:endParaRPr lang="LID4096"/>
+            </a:p>
+          </p:txBody>
+        </p:sp>
+        <p:sp>
+          <p:nvSpPr>
+            <p:cNvPr id="21" name="TextBox 20">
+              <a:extLst>
+                <a:ext uri="{FF2B5EF4-FFF2-40B4-BE49-F238E27FC236}">
+                  <a16:creationId xmlns:a16="http://schemas.microsoft.com/office/drawing/2014/main" id="{434D8251-A858-CA68-F938-77BFAD41CC12}"/>
+                </a:ext>
+              </a:extLst>
+            </p:cNvPr>
+            <p:cNvSpPr txBox="1"/>
+            <p:nvPr/>
+          </p:nvSpPr>
+          <p:spPr>
+            <a:xfrm>
+              <a:off x="5404937" y="1137714"/>
+              <a:ext cx="465950" cy="184666"/>
+            </a:xfrm>
+            <a:prstGeom prst="rect">
+              <a:avLst/>
+            </a:prstGeom>
+            <a:noFill/>
+          </p:spPr>
+          <p:txBody>
+            <a:bodyPr wrap="none" rtlCol="0">
+              <a:spAutoFit/>
+            </a:bodyPr>
+            <a:lstStyle/>
+            <a:p>
+              <a:pPr algn="r"/>
+              <a:r>
+                <a:rPr lang="en-GB" sz="600">
+                  <a:solidFill>
+                    <a:srgbClr val="C00000"/>
+                  </a:solidFill>
+                </a:rPr>
+                <a:t>ingen offset</a:t>
+              </a:r>
+              <a:endParaRPr lang="LID4096" sz="600">
+                <a:solidFill>
+                  <a:srgbClr val="C00000"/>
+                </a:solidFill>
+              </a:endParaRPr>
+            </a:p>
+          </p:txBody>
+        </p:sp>
+      </p:grpSp>
+      <p:grpSp>
+        <p:nvGrpSpPr>
+          <p:cNvPr id="22" name="Group 21">
+            <a:extLst>
+              <a:ext uri="{FF2B5EF4-FFF2-40B4-BE49-F238E27FC236}">
+                <a16:creationId xmlns:a16="http://schemas.microsoft.com/office/drawing/2014/main" id="{91E37CAD-3CAB-C8CD-CF3E-578E32D3ED78}"/>
+              </a:ext>
+            </a:extLst>
+          </p:cNvPr>
+          <p:cNvGrpSpPr/>
+          <p:nvPr/>
+        </p:nvGrpSpPr>
+        <p:grpSpPr>
+          <a:xfrm>
+            <a:off x="5204702" y="5475490"/>
+            <a:ext cx="1489570" cy="280156"/>
+            <a:chOff x="4648477" y="1042224"/>
+            <a:chExt cx="1222410" cy="280156"/>
+          </a:xfrm>
+        </p:grpSpPr>
+        <p:sp>
+          <p:nvSpPr>
+            <p:cNvPr id="23" name="Rectangle 22">
+              <a:extLst>
+                <a:ext uri="{FF2B5EF4-FFF2-40B4-BE49-F238E27FC236}">
+                  <a16:creationId xmlns:a16="http://schemas.microsoft.com/office/drawing/2014/main" id="{0555649E-A4D0-95D8-39F4-8DF0B86C9C09}"/>
+                </a:ext>
+              </a:extLst>
+            </p:cNvPr>
+            <p:cNvSpPr/>
+            <p:nvPr/>
+          </p:nvSpPr>
+          <p:spPr>
+            <a:xfrm>
+              <a:off x="4648477" y="1042224"/>
+              <a:ext cx="1139811" cy="144603"/>
+            </a:xfrm>
+            <a:prstGeom prst="rect">
+              <a:avLst/>
+            </a:prstGeom>
+            <a:noFill/>
+            <a:ln>
+              <a:solidFill>
+                <a:srgbClr val="C00000"/>
+              </a:solidFill>
+            </a:ln>
+          </p:spPr>
+          <p:style>
+            <a:lnRef idx="2">
+              <a:schemeClr val="accent1">
+                <a:shade val="15000"/>
+              </a:schemeClr>
+            </a:lnRef>
+            <a:fillRef idx="1">
+              <a:schemeClr val="accent1"/>
+            </a:fillRef>
+            <a:effectRef idx="0">
+              <a:schemeClr val="accent1"/>
+            </a:effectRef>
+            <a:fontRef idx="minor">
+              <a:schemeClr val="lt1"/>
+            </a:fontRef>
+          </p:style>
+          <p:txBody>
+            <a:bodyPr rtlCol="0" anchor="ctr"/>
+            <a:lstStyle/>
+            <a:p>
+              <a:pPr algn="ctr"/>
+              <a:endParaRPr lang="LID4096"/>
+            </a:p>
+          </p:txBody>
+        </p:sp>
+        <p:sp>
+          <p:nvSpPr>
+            <p:cNvPr id="24" name="TextBox 23">
+              <a:extLst>
+                <a:ext uri="{FF2B5EF4-FFF2-40B4-BE49-F238E27FC236}">
+                  <a16:creationId xmlns:a16="http://schemas.microsoft.com/office/drawing/2014/main" id="{B9B5CDC5-5DEC-FFBB-0491-39E21DB12AF9}"/>
+                </a:ext>
+              </a:extLst>
+            </p:cNvPr>
+            <p:cNvSpPr txBox="1"/>
+            <p:nvPr/>
+          </p:nvSpPr>
+          <p:spPr>
+            <a:xfrm>
+              <a:off x="5329953" y="1137714"/>
+              <a:ext cx="540934" cy="184666"/>
+            </a:xfrm>
+            <a:prstGeom prst="rect">
+              <a:avLst/>
+            </a:prstGeom>
+            <a:noFill/>
+          </p:spPr>
+          <p:txBody>
+            <a:bodyPr wrap="none" rtlCol="0">
+              <a:spAutoFit/>
+            </a:bodyPr>
+            <a:lstStyle/>
+            <a:p>
+              <a:pPr algn="r"/>
+              <a:r>
+                <a:rPr lang="en-GB" sz="600">
+                  <a:solidFill>
+                    <a:srgbClr val="C00000"/>
+                  </a:solidFill>
+                </a:rPr>
+                <a:t>ingen offset x4</a:t>
+              </a:r>
+              <a:endParaRPr lang="LID4096" sz="600">
+                <a:solidFill>
+                  <a:srgbClr val="C00000"/>
+                </a:solidFill>
+              </a:endParaRPr>
+            </a:p>
+          </p:txBody>
+        </p:sp>
+      </p:grpSp>
+      <p:grpSp>
+        <p:nvGrpSpPr>
+          <p:cNvPr id="25" name="Group 24">
+            <a:extLst>
+              <a:ext uri="{FF2B5EF4-FFF2-40B4-BE49-F238E27FC236}">
+                <a16:creationId xmlns:a16="http://schemas.microsoft.com/office/drawing/2014/main" id="{58178360-574D-0C94-A380-1D24F8F80F2C}"/>
+              </a:ext>
+            </a:extLst>
+          </p:cNvPr>
+          <p:cNvGrpSpPr/>
+          <p:nvPr/>
+        </p:nvGrpSpPr>
+        <p:grpSpPr>
+          <a:xfrm>
+            <a:off x="7617593" y="6138071"/>
+            <a:ext cx="1489570" cy="280156"/>
+            <a:chOff x="4648477" y="1042224"/>
+            <a:chExt cx="1222410" cy="280156"/>
+          </a:xfrm>
+        </p:grpSpPr>
+        <p:sp>
+          <p:nvSpPr>
+            <p:cNvPr id="26" name="Rectangle 25">
+              <a:extLst>
+                <a:ext uri="{FF2B5EF4-FFF2-40B4-BE49-F238E27FC236}">
+                  <a16:creationId xmlns:a16="http://schemas.microsoft.com/office/drawing/2014/main" id="{C4858442-797B-2F5E-C93D-53541CA5F171}"/>
+                </a:ext>
+              </a:extLst>
+            </p:cNvPr>
+            <p:cNvSpPr/>
+            <p:nvPr/>
+          </p:nvSpPr>
+          <p:spPr>
+            <a:xfrm>
+              <a:off x="4648477" y="1042224"/>
+              <a:ext cx="1139811" cy="144603"/>
+            </a:xfrm>
+            <a:prstGeom prst="rect">
+              <a:avLst/>
+            </a:prstGeom>
+            <a:noFill/>
+            <a:ln>
+              <a:solidFill>
+                <a:srgbClr val="C00000"/>
+              </a:solidFill>
+            </a:ln>
+          </p:spPr>
+          <p:style>
+            <a:lnRef idx="2">
+              <a:schemeClr val="accent1">
+                <a:shade val="15000"/>
+              </a:schemeClr>
+            </a:lnRef>
+            <a:fillRef idx="1">
+              <a:schemeClr val="accent1"/>
+            </a:fillRef>
+            <a:effectRef idx="0">
+              <a:schemeClr val="accent1"/>
+            </a:effectRef>
+            <a:fontRef idx="minor">
+              <a:schemeClr val="lt1"/>
+            </a:fontRef>
+          </p:style>
+          <p:txBody>
+            <a:bodyPr rtlCol="0" anchor="ctr"/>
+            <a:lstStyle/>
+            <a:p>
+              <a:pPr algn="ctr"/>
+              <a:endParaRPr lang="LID4096"/>
+            </a:p>
+          </p:txBody>
+        </p:sp>
+        <p:sp>
+          <p:nvSpPr>
+            <p:cNvPr id="27" name="TextBox 26">
+              <a:extLst>
+                <a:ext uri="{FF2B5EF4-FFF2-40B4-BE49-F238E27FC236}">
+                  <a16:creationId xmlns:a16="http://schemas.microsoft.com/office/drawing/2014/main" id="{AC617DBB-2298-8482-67E0-5D5F5F781C98}"/>
+                </a:ext>
+              </a:extLst>
+            </p:cNvPr>
+            <p:cNvSpPr txBox="1"/>
+            <p:nvPr/>
+          </p:nvSpPr>
+          <p:spPr>
+            <a:xfrm>
+              <a:off x="5427301" y="1137714"/>
+              <a:ext cx="443586" cy="184666"/>
+            </a:xfrm>
+            <a:prstGeom prst="rect">
+              <a:avLst/>
+            </a:prstGeom>
+            <a:noFill/>
+          </p:spPr>
+          <p:txBody>
+            <a:bodyPr wrap="none" rtlCol="0">
+              <a:spAutoFit/>
+            </a:bodyPr>
+            <a:lstStyle/>
+            <a:p>
+              <a:pPr algn="r"/>
+              <a:r>
+                <a:rPr lang="en-GB" sz="600">
+                  <a:solidFill>
+                    <a:srgbClr val="C00000"/>
+                  </a:solidFill>
+                </a:rPr>
+                <a:t>c </a:t>
+              </a:r>
+              <a:r>
+                <a:rPr lang="sv-SE" sz="600">
+                  <a:solidFill>
+                    <a:srgbClr val="C00000"/>
+                  </a:solidFill>
+                </a:rPr>
+                <a:t>är signed</a:t>
+              </a:r>
+              <a:endParaRPr lang="LID4096" sz="600">
+                <a:solidFill>
+                  <a:srgbClr val="C00000"/>
+                </a:solidFill>
+              </a:endParaRPr>
+            </a:p>
+          </p:txBody>
+        </p:sp>
+      </p:grpSp>
+      <p:grpSp>
+        <p:nvGrpSpPr>
+          <p:cNvPr id="28" name="Group 27">
+            <a:extLst>
+              <a:ext uri="{FF2B5EF4-FFF2-40B4-BE49-F238E27FC236}">
+                <a16:creationId xmlns:a16="http://schemas.microsoft.com/office/drawing/2014/main" id="{5D223B57-A32E-5547-C3F6-F59A43E6A9C9}"/>
+              </a:ext>
+            </a:extLst>
+          </p:cNvPr>
+          <p:cNvGrpSpPr/>
+          <p:nvPr/>
+        </p:nvGrpSpPr>
+        <p:grpSpPr>
+          <a:xfrm>
+            <a:off x="10031138" y="6286803"/>
+            <a:ext cx="1489571" cy="280156"/>
+            <a:chOff x="4648477" y="1042224"/>
+            <a:chExt cx="1222411" cy="280156"/>
+          </a:xfrm>
+        </p:grpSpPr>
+        <p:sp>
+          <p:nvSpPr>
+            <p:cNvPr id="29" name="Rectangle 28">
+              <a:extLst>
+                <a:ext uri="{FF2B5EF4-FFF2-40B4-BE49-F238E27FC236}">
+                  <a16:creationId xmlns:a16="http://schemas.microsoft.com/office/drawing/2014/main" id="{4AC1C9B3-138E-8842-9562-2D5E02B4E74C}"/>
+                </a:ext>
+              </a:extLst>
+            </p:cNvPr>
+            <p:cNvSpPr/>
+            <p:nvPr/>
+          </p:nvSpPr>
+          <p:spPr>
+            <a:xfrm>
+              <a:off x="4648477" y="1042224"/>
+              <a:ext cx="1139811" cy="144603"/>
+            </a:xfrm>
+            <a:prstGeom prst="rect">
+              <a:avLst/>
+            </a:prstGeom>
+            <a:noFill/>
+            <a:ln>
+              <a:solidFill>
+                <a:srgbClr val="C00000"/>
+              </a:solidFill>
+            </a:ln>
+          </p:spPr>
+          <p:style>
+            <a:lnRef idx="2">
+              <a:schemeClr val="accent1">
+                <a:shade val="15000"/>
+              </a:schemeClr>
+            </a:lnRef>
+            <a:fillRef idx="1">
+              <a:schemeClr val="accent1"/>
+            </a:fillRef>
+            <a:effectRef idx="0">
+              <a:schemeClr val="accent1"/>
+            </a:effectRef>
+            <a:fontRef idx="minor">
+              <a:schemeClr val="lt1"/>
+            </a:fontRef>
+          </p:style>
+          <p:txBody>
+            <a:bodyPr rtlCol="0" anchor="ctr"/>
+            <a:lstStyle/>
+            <a:p>
+              <a:pPr algn="ctr"/>
+              <a:endParaRPr lang="LID4096"/>
+            </a:p>
+          </p:txBody>
+        </p:sp>
+        <p:sp>
+          <p:nvSpPr>
+            <p:cNvPr id="30" name="TextBox 29">
+              <a:extLst>
+                <a:ext uri="{FF2B5EF4-FFF2-40B4-BE49-F238E27FC236}">
+                  <a16:creationId xmlns:a16="http://schemas.microsoft.com/office/drawing/2014/main" id="{4702CB70-7AB9-D38C-4DD5-5C2B3F0543AC}"/>
+                </a:ext>
+              </a:extLst>
+            </p:cNvPr>
+            <p:cNvSpPr txBox="1"/>
+            <p:nvPr/>
+          </p:nvSpPr>
+          <p:spPr>
+            <a:xfrm>
+              <a:off x="5418093" y="1137714"/>
+              <a:ext cx="452795" cy="184666"/>
+            </a:xfrm>
+            <a:prstGeom prst="rect">
+              <a:avLst/>
+            </a:prstGeom>
+            <a:noFill/>
+          </p:spPr>
+          <p:txBody>
+            <a:bodyPr wrap="none" rtlCol="0">
+              <a:spAutoFit/>
+            </a:bodyPr>
+            <a:lstStyle/>
+            <a:p>
+              <a:pPr algn="r"/>
+              <a:r>
+                <a:rPr lang="sv-SE" sz="600">
+                  <a:solidFill>
+                    <a:srgbClr val="C00000"/>
+                  </a:solidFill>
+                </a:rPr>
+                <a:t>stores byte</a:t>
+              </a:r>
+              <a:endParaRPr lang="LID4096" sz="600">
+                <a:solidFill>
+                  <a:srgbClr val="C00000"/>
+                </a:solidFill>
+              </a:endParaRPr>
+            </a:p>
+          </p:txBody>
+        </p:sp>
+      </p:grpSp>
+    </p:spTree>
+    <p:extLst>
+      <p:ext uri="{BB962C8B-B14F-4D97-AF65-F5344CB8AC3E}">
+        <p14:creationId xmlns:p14="http://schemas.microsoft.com/office/powerpoint/2010/main" val="3183860259"/>
+      </p:ext>
+    </p:extLst>
+  </p:cSld>
+  <p:clrMapOvr>
+    <a:masterClrMapping/>
+  </p:clrMapOvr>
+  <p:timing>
+    <p:tnLst>
+      <p:par>
+        <p:cTn id="1" dur="indefinite" restart="never" nodeType="tmRoot">
+          <p:childTnLst>
+            <p:seq concurrent="1" nextAc="seek">
+              <p:cTn id="2" dur="indefinite" nodeType="mainSeq">
+                <p:childTnLst>
+                  <p:par>
+                    <p:cTn id="3" fill="hold">
+                      <p:stCondLst>
+                        <p:cond delay="indefinite"/>
+                      </p:stCondLst>
+                      <p:childTnLst>
+                        <p:par>
+                          <p:cTn id="4" fill="hold">
+                            <p:stCondLst>
+                              <p:cond delay="0"/>
+                            </p:stCondLst>
+                            <p:childTnLst>
+                              <p:par>
+                                <p:cTn id="5" presetID="10" presetClass="entr" presetSubtype="0" fill="hold" nodeType="clickEffect">
+                                  <p:stCondLst>
+                                    <p:cond delay="0"/>
+                                  </p:stCondLst>
+                                  <p:childTnLst>
+                                    <p:set>
+                                      <p:cBhvr>
+                                        <p:cTn id="6" dur="1" fill="hold">
+                                          <p:stCondLst>
+                                            <p:cond delay="0"/>
+                                          </p:stCondLst>
+                                        </p:cTn>
+                                        <p:tgtEl>
+                                          <p:spTgt spid="10"/>
+                                        </p:tgtEl>
+                                        <p:attrNameLst>
+                                          <p:attrName>style.visibility</p:attrName>
+                                        </p:attrNameLst>
+                                      </p:cBhvr>
+                                      <p:to>
+                                        <p:strVal val="visible"/>
+                                      </p:to>
+                                    </p:set>
+                                    <p:animEffect transition="in" filter="fade">
+                                      <p:cBhvr>
+                                        <p:cTn id="7" dur="500"/>
+                                        <p:tgtEl>
+                                          <p:spTgt spid="10"/>
+                                        </p:tgtEl>
+                                      </p:cBhvr>
+                                    </p:animEffect>
+                                  </p:childTnLst>
+                                </p:cTn>
+                              </p:par>
+                            </p:childTnLst>
+                          </p:cTn>
+                        </p:par>
+                      </p:childTnLst>
+                    </p:cTn>
+                  </p:par>
+                  <p:par>
+                    <p:cTn id="8" fill="hold">
+                      <p:stCondLst>
+                        <p:cond delay="indefinite"/>
+                      </p:stCondLst>
+                      <p:childTnLst>
+                        <p:par>
+                          <p:cTn id="9" fill="hold">
+                            <p:stCondLst>
+                              <p:cond delay="0"/>
+                            </p:stCondLst>
+                            <p:childTnLst>
+                              <p:par>
+                                <p:cTn id="10" presetID="10" presetClass="entr" presetSubtype="0" fill="hold" nodeType="clickEffect">
+                                  <p:stCondLst>
+                                    <p:cond delay="0"/>
+                                  </p:stCondLst>
+                                  <p:childTnLst>
+                                    <p:set>
+                                      <p:cBhvr>
+                                        <p:cTn id="11" dur="1" fill="hold">
+                                          <p:stCondLst>
+                                            <p:cond delay="0"/>
+                                          </p:stCondLst>
+                                        </p:cTn>
+                                        <p:tgtEl>
+                                          <p:spTgt spid="13"/>
+                                        </p:tgtEl>
+                                        <p:attrNameLst>
+                                          <p:attrName>style.visibility</p:attrName>
+                                        </p:attrNameLst>
+                                      </p:cBhvr>
+                                      <p:to>
+                                        <p:strVal val="visible"/>
+                                      </p:to>
+                                    </p:set>
+                                    <p:animEffect transition="in" filter="fade">
+                                      <p:cBhvr>
+                                        <p:cTn id="12" dur="500"/>
+                                        <p:tgtEl>
+                                          <p:spTgt spid="13"/>
+                                        </p:tgtEl>
+                                      </p:cBhvr>
+                                    </p:animEffect>
+                                  </p:childTnLst>
+                                </p:cTn>
+                              </p:par>
+                            </p:childTnLst>
+                          </p:cTn>
+                        </p:par>
+                      </p:childTnLst>
+                    </p:cTn>
+                  </p:par>
+                  <p:par>
+                    <p:cTn id="13" fill="hold">
+                      <p:stCondLst>
+                        <p:cond delay="indefinite"/>
+                      </p:stCondLst>
+                      <p:childTnLst>
+                        <p:par>
+                          <p:cTn id="14" fill="hold">
+                            <p:stCondLst>
+                              <p:cond delay="0"/>
+                            </p:stCondLst>
+                            <p:childTnLst>
+                              <p:par>
+                                <p:cTn id="15" presetID="10" presetClass="entr" presetSubtype="0" fill="hold" nodeType="clickEffect">
+                                  <p:stCondLst>
+                                    <p:cond delay="0"/>
+                                  </p:stCondLst>
+                                  <p:childTnLst>
+                                    <p:set>
+                                      <p:cBhvr>
+                                        <p:cTn id="16" dur="1" fill="hold">
+                                          <p:stCondLst>
+                                            <p:cond delay="0"/>
+                                          </p:stCondLst>
+                                        </p:cTn>
+                                        <p:tgtEl>
+                                          <p:spTgt spid="16"/>
+                                        </p:tgtEl>
+                                        <p:attrNameLst>
+                                          <p:attrName>style.visibility</p:attrName>
+                                        </p:attrNameLst>
+                                      </p:cBhvr>
+                                      <p:to>
+                                        <p:strVal val="visible"/>
+                                      </p:to>
+                                    </p:set>
+                                    <p:animEffect transition="in" filter="fade">
+                                      <p:cBhvr>
+                                        <p:cTn id="17" dur="500"/>
+                                        <p:tgtEl>
+                                          <p:spTgt spid="16"/>
+                                        </p:tgtEl>
+                                      </p:cBhvr>
+                                    </p:animEffect>
+                                  </p:childTnLst>
+                                </p:cTn>
+                              </p:par>
+                            </p:childTnLst>
+                          </p:cTn>
+                        </p:par>
+                      </p:childTnLst>
+                    </p:cTn>
+                  </p:par>
+                  <p:par>
+                    <p:cTn id="18" fill="hold">
+                      <p:stCondLst>
+                        <p:cond delay="indefinite"/>
+                      </p:stCondLst>
+                      <p:childTnLst>
+                        <p:par>
+                          <p:cTn id="19" fill="hold">
+                            <p:stCondLst>
+                              <p:cond delay="0"/>
+                            </p:stCondLst>
+                            <p:childTnLst>
+                              <p:par>
+                                <p:cTn id="20" presetID="10" presetClass="entr" presetSubtype="0" fill="hold" nodeType="clickEffect">
+                                  <p:stCondLst>
+                                    <p:cond delay="0"/>
+                                  </p:stCondLst>
+                                  <p:childTnLst>
+                                    <p:set>
+                                      <p:cBhvr>
+                                        <p:cTn id="21" dur="1" fill="hold">
+                                          <p:stCondLst>
+                                            <p:cond delay="0"/>
+                                          </p:stCondLst>
+                                        </p:cTn>
+                                        <p:tgtEl>
+                                          <p:spTgt spid="19"/>
+                                        </p:tgtEl>
+                                        <p:attrNameLst>
+                                          <p:attrName>style.visibility</p:attrName>
+                                        </p:attrNameLst>
+                                      </p:cBhvr>
+                                      <p:to>
+                                        <p:strVal val="visible"/>
+                                      </p:to>
+                                    </p:set>
+                                    <p:animEffect transition="in" filter="fade">
+                                      <p:cBhvr>
+                                        <p:cTn id="22" dur="500"/>
+                                        <p:tgtEl>
+                                          <p:spTgt spid="19"/>
+                                        </p:tgtEl>
+                                      </p:cBhvr>
+                                    </p:animEffect>
+                                  </p:childTnLst>
+                                </p:cTn>
+                              </p:par>
+                            </p:childTnLst>
+                          </p:cTn>
+                        </p:par>
+                      </p:childTnLst>
+                    </p:cTn>
+                  </p:par>
+                  <p:par>
+                    <p:cTn id="23" fill="hold">
+                      <p:stCondLst>
+                        <p:cond delay="indefinite"/>
+                      </p:stCondLst>
+                      <p:childTnLst>
+                        <p:par>
+                          <p:cTn id="24" fill="hold">
+                            <p:stCondLst>
+                              <p:cond delay="0"/>
+                            </p:stCondLst>
+                            <p:childTnLst>
+                              <p:par>
+                                <p:cTn id="25" presetID="10" presetClass="entr" presetSubtype="0" fill="hold" nodeType="clickEffect">
+                                  <p:stCondLst>
+                                    <p:cond delay="0"/>
+                                  </p:stCondLst>
+                                  <p:childTnLst>
+                                    <p:set>
+                                      <p:cBhvr>
+                                        <p:cTn id="26" dur="1" fill="hold">
+                                          <p:stCondLst>
+                                            <p:cond delay="0"/>
+                                          </p:stCondLst>
+                                        </p:cTn>
+                                        <p:tgtEl>
+                                          <p:spTgt spid="22"/>
+                                        </p:tgtEl>
+                                        <p:attrNameLst>
+                                          <p:attrName>style.visibility</p:attrName>
+                                        </p:attrNameLst>
+                                      </p:cBhvr>
+                                      <p:to>
+                                        <p:strVal val="visible"/>
+                                      </p:to>
+                                    </p:set>
+                                    <p:animEffect transition="in" filter="fade">
+                                      <p:cBhvr>
+                                        <p:cTn id="27" dur="500"/>
+                                        <p:tgtEl>
+                                          <p:spTgt spid="22"/>
+                                        </p:tgtEl>
+                                      </p:cBhvr>
+                                    </p:animEffect>
+                                  </p:childTnLst>
+                                </p:cTn>
+                              </p:par>
+                            </p:childTnLst>
+                          </p:cTn>
+                        </p:par>
+                      </p:childTnLst>
+                    </p:cTn>
+                  </p:par>
+                  <p:par>
+                    <p:cTn id="28" fill="hold">
+                      <p:stCondLst>
+                        <p:cond delay="indefinite"/>
+                      </p:stCondLst>
+                      <p:childTnLst>
+                        <p:par>
+                          <p:cTn id="29" fill="hold">
+                            <p:stCondLst>
+                              <p:cond delay="0"/>
+                            </p:stCondLst>
+                            <p:childTnLst>
+                              <p:par>
+                                <p:cTn id="30" presetID="10" presetClass="entr" presetSubtype="0" fill="hold" nodeType="clickEffect">
+                                  <p:stCondLst>
+                                    <p:cond delay="0"/>
+                                  </p:stCondLst>
+                                  <p:childTnLst>
+                                    <p:set>
+                                      <p:cBhvr>
+                                        <p:cTn id="31" dur="1" fill="hold">
+                                          <p:stCondLst>
+                                            <p:cond delay="0"/>
+                                          </p:stCondLst>
+                                        </p:cTn>
+                                        <p:tgtEl>
+                                          <p:spTgt spid="25"/>
+                                        </p:tgtEl>
+                                        <p:attrNameLst>
+                                          <p:attrName>style.visibility</p:attrName>
+                                        </p:attrNameLst>
+                                      </p:cBhvr>
+                                      <p:to>
+                                        <p:strVal val="visible"/>
+                                      </p:to>
+                                    </p:set>
+                                    <p:animEffect transition="in" filter="fade">
+                                      <p:cBhvr>
+                                        <p:cTn id="32" dur="500"/>
+                                        <p:tgtEl>
+                                          <p:spTgt spid="25"/>
+                                        </p:tgtEl>
+                                      </p:cBhvr>
+                                    </p:animEffect>
+                                  </p:childTnLst>
+                                </p:cTn>
+                              </p:par>
+                            </p:childTnLst>
+                          </p:cTn>
+                        </p:par>
+                      </p:childTnLst>
+                    </p:cTn>
+                  </p:par>
+                  <p:par>
+                    <p:cTn id="33" fill="hold">
+                      <p:stCondLst>
+                        <p:cond delay="indefinite"/>
+                      </p:stCondLst>
+                      <p:childTnLst>
+                        <p:par>
+                          <p:cTn id="34" fill="hold">
+                            <p:stCondLst>
+                              <p:cond delay="0"/>
+                            </p:stCondLst>
+                            <p:childTnLst>
+                              <p:par>
+                                <p:cTn id="35" presetID="10" presetClass="entr" presetSubtype="0" fill="hold" nodeType="clickEffect">
+                                  <p:stCondLst>
+                                    <p:cond delay="0"/>
+                                  </p:stCondLst>
+                                  <p:childTnLst>
+                                    <p:set>
+                                      <p:cBhvr>
+                                        <p:cTn id="36" dur="1" fill="hold">
+                                          <p:stCondLst>
+                                            <p:cond delay="0"/>
+                                          </p:stCondLst>
+                                        </p:cTn>
+                                        <p:tgtEl>
+                                          <p:spTgt spid="28"/>
+                                        </p:tgtEl>
+                                        <p:attrNameLst>
+                                          <p:attrName>style.visibility</p:attrName>
+                                        </p:attrNameLst>
+                                      </p:cBhvr>
+                                      <p:to>
+                                        <p:strVal val="visible"/>
+                                      </p:to>
+                                    </p:set>
+                                    <p:animEffect transition="in" filter="fade">
+                                      <p:cBhvr>
+                                        <p:cTn id="37" dur="500"/>
+                                        <p:tgtEl>
+                                          <p:spTgt spid="28"/>
+                                        </p:tgtEl>
+                                      </p:cBhvr>
+                                    </p:animEffect>
+                                  </p:childTnLst>
+                                </p:cTn>
+                              </p:par>
+                            </p:childTnLst>
+                          </p:cTn>
+                        </p:par>
+                      </p:childTnLst>
+                    </p:cTn>
+                  </p:par>
+                </p:childTnLst>
+              </p:cTn>
+              <p:prevCondLst>
+                <p:cond evt="onPrev" delay="0">
+                  <p:tgtEl>
+                    <p:sldTgt/>
+                  </p:tgtEl>
+                </p:cond>
+              </p:prevCondLst>
+              <p:nextCondLst>
+                <p:cond evt="onNext" delay="0">
+                  <p:tgtEl>
+                    <p:sldTgt/>
+                  </p:tgtEl>
+                </p:cond>
+              </p:nextCondLst>
+            </p:seq>
+          </p:childTnLst>
+        </p:cTn>
+      </p:par>
+    </p:tnLst>
+  </p:timing>
+</p:sld>
+</file>
+
+<file path=ppt/slides/slide3.xml><?xml version="1.0" encoding="utf-8"?>
+<p:sld xmlns:a="http://schemas.openxmlformats.org/drawingml/2006/main" xmlns:r="http://schemas.openxmlformats.org/officeDocument/2006/relationships" xmlns:p="http://schemas.openxmlformats.org/presentationml/2006/main">
+  <p:cSld>
+    <p:spTree>
+      <p:nvGrpSpPr>
+        <p:cNvPr id="1" name=""/>
+        <p:cNvGrpSpPr/>
+        <p:nvPr/>
+      </p:nvGrpSpPr>
+      <p:grpSpPr>
+        <a:xfrm>
+          <a:off x="0" y="0"/>
+          <a:ext cx="0" cy="0"/>
+          <a:chOff x="0" y="0"/>
+          <a:chExt cx="0" cy="0"/>
+        </a:xfrm>
+      </p:grpSpPr>
+      <p:pic>
+        <p:nvPicPr>
           <p:cNvPr id="49" name="Picture 48">
             <a:extLst>
               <a:ext uri="{FF2B5EF4-FFF2-40B4-BE49-F238E27FC236}">
@@ -4675,7 +7355,7 @@
 </p:sld>
 </file>
 
-<file path=ppt/slides/slide2.xml><?xml version="1.0" encoding="utf-8"?>
+<file path=ppt/slides/slide4.xml><?xml version="1.0" encoding="utf-8"?>
 <p:sld xmlns:a="http://schemas.openxmlformats.org/drawingml/2006/main" xmlns:r="http://schemas.openxmlformats.org/officeDocument/2006/relationships" xmlns:p="http://schemas.openxmlformats.org/presentationml/2006/main">
   <p:cSld>
     <p:spTree>
@@ -6511,7 +9191,7 @@
 </p:sld>
 </file>
 
-<file path=ppt/slides/slide3.xml><?xml version="1.0" encoding="utf-8"?>
+<file path=ppt/slides/slide5.xml><?xml version="1.0" encoding="utf-8"?>
 <p:sld xmlns:a="http://schemas.openxmlformats.org/drawingml/2006/main" xmlns:r="http://schemas.openxmlformats.org/officeDocument/2006/relationships" xmlns:p="http://schemas.openxmlformats.org/presentationml/2006/main">
   <p:cSld>
     <p:spTree>
@@ -7586,7 +10266,7 @@
 </p:sld>
 </file>
 
-<file path=ppt/slides/slide4.xml><?xml version="1.0" encoding="utf-8"?>
+<file path=ppt/slides/slide6.xml><?xml version="1.0" encoding="utf-8"?>
 <p:sld xmlns:a="http://schemas.openxmlformats.org/drawingml/2006/main" xmlns:r="http://schemas.openxmlformats.org/officeDocument/2006/relationships" xmlns:p="http://schemas.openxmlformats.org/presentationml/2006/main">
   <p:cSld>
     <p:spTree>
@@ -8561,6 +11241,1375 @@
 </p:sld>
 </file>
 
+<file path=ppt/slides/slide7.xml><?xml version="1.0" encoding="utf-8"?>
+<p:sld xmlns:a="http://schemas.openxmlformats.org/drawingml/2006/main" xmlns:r="http://schemas.openxmlformats.org/officeDocument/2006/relationships" xmlns:p="http://schemas.openxmlformats.org/presentationml/2006/main">
+  <p:cSld>
+    <p:spTree>
+      <p:nvGrpSpPr>
+        <p:cNvPr id="1" name=""/>
+        <p:cNvGrpSpPr/>
+        <p:nvPr/>
+      </p:nvGrpSpPr>
+      <p:grpSpPr>
+        <a:xfrm>
+          <a:off x="0" y="0"/>
+          <a:ext cx="0" cy="0"/>
+          <a:chOff x="0" y="0"/>
+          <a:chExt cx="0" cy="0"/>
+        </a:xfrm>
+      </p:grpSpPr>
+      <p:pic>
+        <p:nvPicPr>
+          <p:cNvPr id="5" name="Picture 4">
+            <a:extLst>
+              <a:ext uri="{FF2B5EF4-FFF2-40B4-BE49-F238E27FC236}">
+                <a16:creationId xmlns:a16="http://schemas.microsoft.com/office/drawing/2014/main" id="{5C31C835-1997-22A6-7614-3D6D3DC0D2E0}"/>
+              </a:ext>
+            </a:extLst>
+          </p:cNvPr>
+          <p:cNvPicPr>
+            <a:picLocks noChangeAspect="1"/>
+          </p:cNvPicPr>
+          <p:nvPr/>
+        </p:nvPicPr>
+        <p:blipFill>
+          <a:blip r:embed="rId2"/>
+          <a:stretch>
+            <a:fillRect/>
+          </a:stretch>
+        </p:blipFill>
+        <p:spPr>
+          <a:xfrm>
+            <a:off x="0" y="0"/>
+            <a:ext cx="3535558" cy="2703955"/>
+          </a:xfrm>
+          <a:prstGeom prst="rect">
+            <a:avLst/>
+          </a:prstGeom>
+        </p:spPr>
+      </p:pic>
+      <p:pic>
+        <p:nvPicPr>
+          <p:cNvPr id="7" name="Picture 6">
+            <a:extLst>
+              <a:ext uri="{FF2B5EF4-FFF2-40B4-BE49-F238E27FC236}">
+                <a16:creationId xmlns:a16="http://schemas.microsoft.com/office/drawing/2014/main" id="{F1D2F0AD-667E-E897-40A8-E6696EFFF5C7}"/>
+              </a:ext>
+            </a:extLst>
+          </p:cNvPr>
+          <p:cNvPicPr>
+            <a:picLocks noChangeAspect="1"/>
+          </p:cNvPicPr>
+          <p:nvPr/>
+        </p:nvPicPr>
+        <p:blipFill>
+          <a:blip r:embed="rId3"/>
+          <a:stretch>
+            <a:fillRect/>
+          </a:stretch>
+        </p:blipFill>
+        <p:spPr>
+          <a:xfrm>
+            <a:off x="3741832" y="0"/>
+            <a:ext cx="4708336" cy="6858000"/>
+          </a:xfrm>
+          <a:prstGeom prst="rect">
+            <a:avLst/>
+          </a:prstGeom>
+        </p:spPr>
+      </p:pic>
+      <p:grpSp>
+        <p:nvGrpSpPr>
+          <p:cNvPr id="8" name="Group 7">
+            <a:extLst>
+              <a:ext uri="{FF2B5EF4-FFF2-40B4-BE49-F238E27FC236}">
+                <a16:creationId xmlns:a16="http://schemas.microsoft.com/office/drawing/2014/main" id="{3F7FABC6-A94F-AB50-B29A-A8325CEA4E0A}"/>
+              </a:ext>
+            </a:extLst>
+          </p:cNvPr>
+          <p:cNvGrpSpPr/>
+          <p:nvPr/>
+        </p:nvGrpSpPr>
+        <p:grpSpPr>
+          <a:xfrm>
+            <a:off x="4012444" y="918814"/>
+            <a:ext cx="1671314" cy="280156"/>
+            <a:chOff x="4648477" y="1042224"/>
+            <a:chExt cx="1222410" cy="280156"/>
+          </a:xfrm>
+        </p:grpSpPr>
+        <p:sp>
+          <p:nvSpPr>
+            <p:cNvPr id="9" name="Rectangle 8">
+              <a:extLst>
+                <a:ext uri="{FF2B5EF4-FFF2-40B4-BE49-F238E27FC236}">
+                  <a16:creationId xmlns:a16="http://schemas.microsoft.com/office/drawing/2014/main" id="{F2546071-DB03-528E-96F6-38E5DFC88BB1}"/>
+                </a:ext>
+              </a:extLst>
+            </p:cNvPr>
+            <p:cNvSpPr/>
+            <p:nvPr/>
+          </p:nvSpPr>
+          <p:spPr>
+            <a:xfrm>
+              <a:off x="4648477" y="1042224"/>
+              <a:ext cx="1139811" cy="144603"/>
+            </a:xfrm>
+            <a:prstGeom prst="rect">
+              <a:avLst/>
+            </a:prstGeom>
+            <a:noFill/>
+            <a:ln>
+              <a:solidFill>
+                <a:srgbClr val="C00000"/>
+              </a:solidFill>
+            </a:ln>
+          </p:spPr>
+          <p:style>
+            <a:lnRef idx="2">
+              <a:schemeClr val="accent1">
+                <a:shade val="15000"/>
+              </a:schemeClr>
+            </a:lnRef>
+            <a:fillRef idx="1">
+              <a:schemeClr val="accent1"/>
+            </a:fillRef>
+            <a:effectRef idx="0">
+              <a:schemeClr val="accent1"/>
+            </a:effectRef>
+            <a:fontRef idx="minor">
+              <a:schemeClr val="lt1"/>
+            </a:fontRef>
+          </p:style>
+          <p:txBody>
+            <a:bodyPr rtlCol="0" anchor="ctr"/>
+            <a:lstStyle/>
+            <a:p>
+              <a:pPr algn="ctr"/>
+              <a:endParaRPr lang="LID4096"/>
+            </a:p>
+          </p:txBody>
+        </p:sp>
+        <p:sp>
+          <p:nvSpPr>
+            <p:cNvPr id="10" name="TextBox 9">
+              <a:extLst>
+                <a:ext uri="{FF2B5EF4-FFF2-40B4-BE49-F238E27FC236}">
+                  <a16:creationId xmlns:a16="http://schemas.microsoft.com/office/drawing/2014/main" id="{5248AD13-6F43-E24F-7A7B-79DA3010CFDD}"/>
+                </a:ext>
+              </a:extLst>
+            </p:cNvPr>
+            <p:cNvSpPr txBox="1"/>
+            <p:nvPr/>
+          </p:nvSpPr>
+          <p:spPr>
+            <a:xfrm>
+              <a:off x="5113251" y="1137714"/>
+              <a:ext cx="757636" cy="184666"/>
+            </a:xfrm>
+            <a:prstGeom prst="rect">
+              <a:avLst/>
+            </a:prstGeom>
+            <a:noFill/>
+          </p:spPr>
+          <p:txBody>
+            <a:bodyPr wrap="none" rtlCol="0">
+              <a:spAutoFit/>
+            </a:bodyPr>
+            <a:lstStyle/>
+            <a:p>
+              <a:pPr algn="r"/>
+              <a:r>
+                <a:rPr lang="sv-SE" sz="600">
+                  <a:solidFill>
+                    <a:srgbClr val="C00000"/>
+                  </a:solidFill>
+                </a:rPr>
+                <a:t>ökar pekaren med 4 bytes</a:t>
+              </a:r>
+              <a:endParaRPr lang="LID4096" sz="600">
+                <a:solidFill>
+                  <a:srgbClr val="C00000"/>
+                </a:solidFill>
+              </a:endParaRPr>
+            </a:p>
+          </p:txBody>
+        </p:sp>
+      </p:grpSp>
+      <p:grpSp>
+        <p:nvGrpSpPr>
+          <p:cNvPr id="11" name="Group 10">
+            <a:extLst>
+              <a:ext uri="{FF2B5EF4-FFF2-40B4-BE49-F238E27FC236}">
+                <a16:creationId xmlns:a16="http://schemas.microsoft.com/office/drawing/2014/main" id="{60860772-C8FB-B24F-B7C0-ACFE709BEEB7}"/>
+              </a:ext>
+            </a:extLst>
+          </p:cNvPr>
+          <p:cNvGrpSpPr/>
+          <p:nvPr/>
+        </p:nvGrpSpPr>
+        <p:grpSpPr>
+          <a:xfrm>
+            <a:off x="6772265" y="349111"/>
+            <a:ext cx="1300356" cy="340724"/>
+            <a:chOff x="3335893" y="1042224"/>
+            <a:chExt cx="6160496" cy="315714"/>
+          </a:xfrm>
+        </p:grpSpPr>
+        <p:sp>
+          <p:nvSpPr>
+            <p:cNvPr id="12" name="Rectangle 11">
+              <a:extLst>
+                <a:ext uri="{FF2B5EF4-FFF2-40B4-BE49-F238E27FC236}">
+                  <a16:creationId xmlns:a16="http://schemas.microsoft.com/office/drawing/2014/main" id="{0463F7E5-249F-0A7D-4E08-536BD6234CFA}"/>
+                </a:ext>
+              </a:extLst>
+            </p:cNvPr>
+            <p:cNvSpPr/>
+            <p:nvPr/>
+          </p:nvSpPr>
+          <p:spPr>
+            <a:xfrm>
+              <a:off x="4648477" y="1042224"/>
+              <a:ext cx="1139811" cy="144603"/>
+            </a:xfrm>
+            <a:prstGeom prst="rect">
+              <a:avLst/>
+            </a:prstGeom>
+            <a:noFill/>
+            <a:ln>
+              <a:solidFill>
+                <a:srgbClr val="C00000"/>
+              </a:solidFill>
+            </a:ln>
+          </p:spPr>
+          <p:style>
+            <a:lnRef idx="2">
+              <a:schemeClr val="accent1">
+                <a:shade val="15000"/>
+              </a:schemeClr>
+            </a:lnRef>
+            <a:fillRef idx="1">
+              <a:schemeClr val="accent1"/>
+            </a:fillRef>
+            <a:effectRef idx="0">
+              <a:schemeClr val="accent1"/>
+            </a:effectRef>
+            <a:fontRef idx="minor">
+              <a:schemeClr val="lt1"/>
+            </a:fontRef>
+          </p:style>
+          <p:txBody>
+            <a:bodyPr rtlCol="0" anchor="ctr"/>
+            <a:lstStyle/>
+            <a:p>
+              <a:pPr algn="ctr"/>
+              <a:endParaRPr lang="LID4096"/>
+            </a:p>
+          </p:txBody>
+        </p:sp>
+        <p:sp>
+          <p:nvSpPr>
+            <p:cNvPr id="13" name="TextBox 12">
+              <a:extLst>
+                <a:ext uri="{FF2B5EF4-FFF2-40B4-BE49-F238E27FC236}">
+                  <a16:creationId xmlns:a16="http://schemas.microsoft.com/office/drawing/2014/main" id="{E0031A94-1E22-6FAF-B240-45740E2D33DE}"/>
+                </a:ext>
+              </a:extLst>
+            </p:cNvPr>
+            <p:cNvSpPr txBox="1"/>
+            <p:nvPr/>
+          </p:nvSpPr>
+          <p:spPr>
+            <a:xfrm>
+              <a:off x="3335893" y="1186827"/>
+              <a:ext cx="6160496" cy="171111"/>
+            </a:xfrm>
+            <a:prstGeom prst="rect">
+              <a:avLst/>
+            </a:prstGeom>
+            <a:noFill/>
+          </p:spPr>
+          <p:txBody>
+            <a:bodyPr wrap="none" rtlCol="0">
+              <a:spAutoFit/>
+            </a:bodyPr>
+            <a:lstStyle/>
+            <a:p>
+              <a:pPr algn="r"/>
+              <a:r>
+                <a:rPr lang="sv-SE" sz="600">
+                  <a:solidFill>
+                    <a:srgbClr val="C00000"/>
+                  </a:solidFill>
+                </a:rPr>
+                <a:t>orginalvärdet kommer inte ändras</a:t>
+              </a:r>
+              <a:endParaRPr lang="LID4096" sz="600">
+                <a:solidFill>
+                  <a:srgbClr val="C00000"/>
+                </a:solidFill>
+              </a:endParaRPr>
+            </a:p>
+          </p:txBody>
+        </p:sp>
+      </p:grpSp>
+      <p:grpSp>
+        <p:nvGrpSpPr>
+          <p:cNvPr id="14" name="Group 13">
+            <a:extLst>
+              <a:ext uri="{FF2B5EF4-FFF2-40B4-BE49-F238E27FC236}">
+                <a16:creationId xmlns:a16="http://schemas.microsoft.com/office/drawing/2014/main" id="{4688FB28-238A-F3EB-C3CC-0E746E4321B0}"/>
+              </a:ext>
+            </a:extLst>
+          </p:cNvPr>
+          <p:cNvGrpSpPr/>
+          <p:nvPr/>
+        </p:nvGrpSpPr>
+        <p:grpSpPr>
+          <a:xfrm>
+            <a:off x="7002493" y="2459602"/>
+            <a:ext cx="1511688" cy="525390"/>
+            <a:chOff x="4569275" y="871113"/>
+            <a:chExt cx="7161691" cy="486825"/>
+          </a:xfrm>
+        </p:grpSpPr>
+        <p:sp>
+          <p:nvSpPr>
+            <p:cNvPr id="15" name="Rectangle 14">
+              <a:extLst>
+                <a:ext uri="{FF2B5EF4-FFF2-40B4-BE49-F238E27FC236}">
+                  <a16:creationId xmlns:a16="http://schemas.microsoft.com/office/drawing/2014/main" id="{F12F542B-47B2-C763-8E7A-98D97BD12B96}"/>
+                </a:ext>
+              </a:extLst>
+            </p:cNvPr>
+            <p:cNvSpPr/>
+            <p:nvPr/>
+          </p:nvSpPr>
+          <p:spPr>
+            <a:xfrm>
+              <a:off x="4648477" y="1042224"/>
+              <a:ext cx="3001197" cy="144603"/>
+            </a:xfrm>
+            <a:prstGeom prst="rect">
+              <a:avLst/>
+            </a:prstGeom>
+            <a:noFill/>
+            <a:ln>
+              <a:solidFill>
+                <a:srgbClr val="C00000"/>
+              </a:solidFill>
+            </a:ln>
+          </p:spPr>
+          <p:style>
+            <a:lnRef idx="2">
+              <a:schemeClr val="accent1">
+                <a:shade val="15000"/>
+              </a:schemeClr>
+            </a:lnRef>
+            <a:fillRef idx="1">
+              <a:schemeClr val="accent1"/>
+            </a:fillRef>
+            <a:effectRef idx="0">
+              <a:schemeClr val="accent1"/>
+            </a:effectRef>
+            <a:fontRef idx="minor">
+              <a:schemeClr val="lt1"/>
+            </a:fontRef>
+          </p:style>
+          <p:txBody>
+            <a:bodyPr rtlCol="0" anchor="ctr"/>
+            <a:lstStyle/>
+            <a:p>
+              <a:pPr algn="ctr"/>
+              <a:endParaRPr lang="LID4096"/>
+            </a:p>
+          </p:txBody>
+        </p:sp>
+        <p:sp>
+          <p:nvSpPr>
+            <p:cNvPr id="16" name="TextBox 15">
+              <a:extLst>
+                <a:ext uri="{FF2B5EF4-FFF2-40B4-BE49-F238E27FC236}">
+                  <a16:creationId xmlns:a16="http://schemas.microsoft.com/office/drawing/2014/main" id="{DA076F22-6FF2-AB27-5CF1-5B4B7B327632}"/>
+                </a:ext>
+              </a:extLst>
+            </p:cNvPr>
+            <p:cNvSpPr txBox="1"/>
+            <p:nvPr/>
+          </p:nvSpPr>
+          <p:spPr>
+            <a:xfrm>
+              <a:off x="4569275" y="871113"/>
+              <a:ext cx="6160799" cy="256667"/>
+            </a:xfrm>
+            <a:prstGeom prst="rect">
+              <a:avLst/>
+            </a:prstGeom>
+            <a:noFill/>
+          </p:spPr>
+          <p:txBody>
+            <a:bodyPr wrap="none" rtlCol="0">
+              <a:spAutoFit/>
+            </a:bodyPr>
+            <a:lstStyle/>
+            <a:p>
+              <a:pPr algn="r"/>
+              <a:r>
+                <a:rPr lang="sv-SE" sz="600">
+                  <a:solidFill>
+                    <a:srgbClr val="C00000"/>
+                  </a:solidFill>
+                </a:rPr>
+                <a:t>orginalvärdet kommer inte ändras</a:t>
+              </a:r>
+              <a:br>
+                <a:rPr lang="sv-SE" sz="600">
+                  <a:solidFill>
+                    <a:srgbClr val="C00000"/>
+                  </a:solidFill>
+                </a:rPr>
+              </a:br>
+              <a:endParaRPr lang="LID4096" sz="600">
+                <a:solidFill>
+                  <a:srgbClr val="C00000"/>
+                </a:solidFill>
+              </a:endParaRPr>
+            </a:p>
+          </p:txBody>
+        </p:sp>
+        <p:sp>
+          <p:nvSpPr>
+            <p:cNvPr id="17" name="TextBox 16">
+              <a:extLst>
+                <a:ext uri="{FF2B5EF4-FFF2-40B4-BE49-F238E27FC236}">
+                  <a16:creationId xmlns:a16="http://schemas.microsoft.com/office/drawing/2014/main" id="{B1C91A16-A9AA-B8D6-D52D-B50381F77E73}"/>
+                </a:ext>
+              </a:extLst>
+            </p:cNvPr>
+            <p:cNvSpPr txBox="1"/>
+            <p:nvPr/>
+          </p:nvSpPr>
+          <p:spPr>
+            <a:xfrm>
+              <a:off x="5562876" y="1186827"/>
+              <a:ext cx="6168090" cy="171111"/>
+            </a:xfrm>
+            <a:prstGeom prst="rect">
+              <a:avLst/>
+            </a:prstGeom>
+            <a:noFill/>
+          </p:spPr>
+          <p:txBody>
+            <a:bodyPr wrap="none" rtlCol="0">
+              <a:spAutoFit/>
+            </a:bodyPr>
+            <a:lstStyle/>
+            <a:p>
+              <a:pPr algn="r"/>
+              <a:r>
+                <a:rPr lang="sv-SE" sz="600">
+                  <a:solidFill>
+                    <a:srgbClr val="C00000"/>
+                  </a:solidFill>
+                </a:rPr>
+                <a:t>(m är en pekare men det är okay?)</a:t>
+              </a:r>
+              <a:endParaRPr lang="LID4096" sz="600">
+                <a:solidFill>
+                  <a:srgbClr val="C00000"/>
+                </a:solidFill>
+              </a:endParaRPr>
+            </a:p>
+          </p:txBody>
+        </p:sp>
+      </p:grpSp>
+      <p:grpSp>
+        <p:nvGrpSpPr>
+          <p:cNvPr id="18" name="Group 17">
+            <a:extLst>
+              <a:ext uri="{FF2B5EF4-FFF2-40B4-BE49-F238E27FC236}">
+                <a16:creationId xmlns:a16="http://schemas.microsoft.com/office/drawing/2014/main" id="{A3824CB8-F219-ED60-311F-C838D523F620}"/>
+              </a:ext>
+            </a:extLst>
+          </p:cNvPr>
+          <p:cNvGrpSpPr/>
+          <p:nvPr/>
+        </p:nvGrpSpPr>
+        <p:grpSpPr>
+          <a:xfrm>
+            <a:off x="4012444" y="5563540"/>
+            <a:ext cx="1671314" cy="280156"/>
+            <a:chOff x="4648477" y="1042224"/>
+            <a:chExt cx="1222410" cy="280156"/>
+          </a:xfrm>
+        </p:grpSpPr>
+        <p:sp>
+          <p:nvSpPr>
+            <p:cNvPr id="19" name="Rectangle 18">
+              <a:extLst>
+                <a:ext uri="{FF2B5EF4-FFF2-40B4-BE49-F238E27FC236}">
+                  <a16:creationId xmlns:a16="http://schemas.microsoft.com/office/drawing/2014/main" id="{510EEEC6-B2CB-69DE-591D-FFD26E740CC4}"/>
+                </a:ext>
+              </a:extLst>
+            </p:cNvPr>
+            <p:cNvSpPr/>
+            <p:nvPr/>
+          </p:nvSpPr>
+          <p:spPr>
+            <a:xfrm>
+              <a:off x="4648477" y="1042224"/>
+              <a:ext cx="1139811" cy="144603"/>
+            </a:xfrm>
+            <a:prstGeom prst="rect">
+              <a:avLst/>
+            </a:prstGeom>
+            <a:noFill/>
+            <a:ln>
+              <a:solidFill>
+                <a:srgbClr val="C00000"/>
+              </a:solidFill>
+            </a:ln>
+          </p:spPr>
+          <p:style>
+            <a:lnRef idx="2">
+              <a:schemeClr val="accent1">
+                <a:shade val="15000"/>
+              </a:schemeClr>
+            </a:lnRef>
+            <a:fillRef idx="1">
+              <a:schemeClr val="accent1"/>
+            </a:fillRef>
+            <a:effectRef idx="0">
+              <a:schemeClr val="accent1"/>
+            </a:effectRef>
+            <a:fontRef idx="minor">
+              <a:schemeClr val="lt1"/>
+            </a:fontRef>
+          </p:style>
+          <p:txBody>
+            <a:bodyPr rtlCol="0" anchor="ctr"/>
+            <a:lstStyle/>
+            <a:p>
+              <a:pPr algn="ctr"/>
+              <a:endParaRPr lang="LID4096"/>
+            </a:p>
+          </p:txBody>
+        </p:sp>
+        <p:sp>
+          <p:nvSpPr>
+            <p:cNvPr id="20" name="TextBox 19">
+              <a:extLst>
+                <a:ext uri="{FF2B5EF4-FFF2-40B4-BE49-F238E27FC236}">
+                  <a16:creationId xmlns:a16="http://schemas.microsoft.com/office/drawing/2014/main" id="{58804F01-261D-B381-AA59-32CAECC8746A}"/>
+                </a:ext>
+              </a:extLst>
+            </p:cNvPr>
+            <p:cNvSpPr txBox="1"/>
+            <p:nvPr/>
+          </p:nvSpPr>
+          <p:spPr>
+            <a:xfrm>
+              <a:off x="5586920" y="1137714"/>
+              <a:ext cx="283967" cy="184666"/>
+            </a:xfrm>
+            <a:prstGeom prst="rect">
+              <a:avLst/>
+            </a:prstGeom>
+            <a:noFill/>
+          </p:spPr>
+          <p:txBody>
+            <a:bodyPr wrap="none" rtlCol="0">
+              <a:spAutoFit/>
+            </a:bodyPr>
+            <a:lstStyle/>
+            <a:p>
+              <a:pPr algn="r"/>
+              <a:r>
+                <a:rPr lang="sv-SE" sz="600">
+                  <a:solidFill>
+                    <a:srgbClr val="C00000"/>
+                  </a:solidFill>
+                </a:rPr>
+                <a:t>what?</a:t>
+              </a:r>
+              <a:endParaRPr lang="LID4096" sz="600">
+                <a:solidFill>
+                  <a:srgbClr val="C00000"/>
+                </a:solidFill>
+              </a:endParaRPr>
+            </a:p>
+          </p:txBody>
+        </p:sp>
+      </p:grpSp>
+      <p:grpSp>
+        <p:nvGrpSpPr>
+          <p:cNvPr id="24" name="Group 23">
+            <a:extLst>
+              <a:ext uri="{FF2B5EF4-FFF2-40B4-BE49-F238E27FC236}">
+                <a16:creationId xmlns:a16="http://schemas.microsoft.com/office/drawing/2014/main" id="{C3DC4946-099C-5B30-01E6-CA01F1F1DCE9}"/>
+              </a:ext>
+            </a:extLst>
+          </p:cNvPr>
+          <p:cNvGrpSpPr/>
+          <p:nvPr/>
+        </p:nvGrpSpPr>
+        <p:grpSpPr>
+          <a:xfrm>
+            <a:off x="6401779" y="5545879"/>
+            <a:ext cx="1671314" cy="280156"/>
+            <a:chOff x="4648477" y="1042224"/>
+            <a:chExt cx="1222410" cy="280156"/>
+          </a:xfrm>
+        </p:grpSpPr>
+        <p:sp>
+          <p:nvSpPr>
+            <p:cNvPr id="25" name="Rectangle 24">
+              <a:extLst>
+                <a:ext uri="{FF2B5EF4-FFF2-40B4-BE49-F238E27FC236}">
+                  <a16:creationId xmlns:a16="http://schemas.microsoft.com/office/drawing/2014/main" id="{B511571C-866C-FE2C-AD7A-CD81F25FBF69}"/>
+                </a:ext>
+              </a:extLst>
+            </p:cNvPr>
+            <p:cNvSpPr/>
+            <p:nvPr/>
+          </p:nvSpPr>
+          <p:spPr>
+            <a:xfrm>
+              <a:off x="4648477" y="1042224"/>
+              <a:ext cx="1139811" cy="144603"/>
+            </a:xfrm>
+            <a:prstGeom prst="rect">
+              <a:avLst/>
+            </a:prstGeom>
+            <a:noFill/>
+            <a:ln>
+              <a:solidFill>
+                <a:srgbClr val="C00000"/>
+              </a:solidFill>
+            </a:ln>
+          </p:spPr>
+          <p:style>
+            <a:lnRef idx="2">
+              <a:schemeClr val="accent1">
+                <a:shade val="15000"/>
+              </a:schemeClr>
+            </a:lnRef>
+            <a:fillRef idx="1">
+              <a:schemeClr val="accent1"/>
+            </a:fillRef>
+            <a:effectRef idx="0">
+              <a:schemeClr val="accent1"/>
+            </a:effectRef>
+            <a:fontRef idx="minor">
+              <a:schemeClr val="lt1"/>
+            </a:fontRef>
+          </p:style>
+          <p:txBody>
+            <a:bodyPr rtlCol="0" anchor="ctr"/>
+            <a:lstStyle/>
+            <a:p>
+              <a:pPr algn="ctr"/>
+              <a:endParaRPr lang="LID4096"/>
+            </a:p>
+          </p:txBody>
+        </p:sp>
+        <p:sp>
+          <p:nvSpPr>
+            <p:cNvPr id="26" name="TextBox 25">
+              <a:extLst>
+                <a:ext uri="{FF2B5EF4-FFF2-40B4-BE49-F238E27FC236}">
+                  <a16:creationId xmlns:a16="http://schemas.microsoft.com/office/drawing/2014/main" id="{C862D47A-B039-6D1E-CCE8-BB05DB91A1DE}"/>
+                </a:ext>
+              </a:extLst>
+            </p:cNvPr>
+            <p:cNvSpPr txBox="1"/>
+            <p:nvPr/>
+          </p:nvSpPr>
+          <p:spPr>
+            <a:xfrm>
+              <a:off x="5113251" y="1137714"/>
+              <a:ext cx="757636" cy="184666"/>
+            </a:xfrm>
+            <a:prstGeom prst="rect">
+              <a:avLst/>
+            </a:prstGeom>
+            <a:noFill/>
+          </p:spPr>
+          <p:txBody>
+            <a:bodyPr wrap="none" rtlCol="0">
+              <a:spAutoFit/>
+            </a:bodyPr>
+            <a:lstStyle/>
+            <a:p>
+              <a:pPr algn="r"/>
+              <a:r>
+                <a:rPr lang="sv-SE" sz="600">
+                  <a:solidFill>
+                    <a:srgbClr val="C00000"/>
+                  </a:solidFill>
+                </a:rPr>
+                <a:t>ökar pekaren med 4 bytes</a:t>
+              </a:r>
+              <a:endParaRPr lang="LID4096" sz="600">
+                <a:solidFill>
+                  <a:srgbClr val="C00000"/>
+                </a:solidFill>
+              </a:endParaRPr>
+            </a:p>
+          </p:txBody>
+        </p:sp>
+      </p:grpSp>
+      <p:grpSp>
+        <p:nvGrpSpPr>
+          <p:cNvPr id="27" name="Group 26">
+            <a:extLst>
+              <a:ext uri="{FF2B5EF4-FFF2-40B4-BE49-F238E27FC236}">
+                <a16:creationId xmlns:a16="http://schemas.microsoft.com/office/drawing/2014/main" id="{454DD465-A1C3-52C5-B3D7-A0B9E32BE1D1}"/>
+              </a:ext>
+            </a:extLst>
+          </p:cNvPr>
+          <p:cNvGrpSpPr/>
+          <p:nvPr/>
+        </p:nvGrpSpPr>
+        <p:grpSpPr>
+          <a:xfrm>
+            <a:off x="8791114" y="10172944"/>
+            <a:ext cx="1671312" cy="280156"/>
+            <a:chOff x="4648477" y="1042224"/>
+            <a:chExt cx="1222408" cy="280156"/>
+          </a:xfrm>
+        </p:grpSpPr>
+        <p:sp>
+          <p:nvSpPr>
+            <p:cNvPr id="28" name="Rectangle 27">
+              <a:extLst>
+                <a:ext uri="{FF2B5EF4-FFF2-40B4-BE49-F238E27FC236}">
+                  <a16:creationId xmlns:a16="http://schemas.microsoft.com/office/drawing/2014/main" id="{C4793841-4446-3604-A23C-D7D269ACEB83}"/>
+                </a:ext>
+              </a:extLst>
+            </p:cNvPr>
+            <p:cNvSpPr/>
+            <p:nvPr/>
+          </p:nvSpPr>
+          <p:spPr>
+            <a:xfrm>
+              <a:off x="4648477" y="1042224"/>
+              <a:ext cx="1139810" cy="144603"/>
+            </a:xfrm>
+            <a:prstGeom prst="rect">
+              <a:avLst/>
+            </a:prstGeom>
+            <a:noFill/>
+            <a:ln>
+              <a:solidFill>
+                <a:srgbClr val="C00000"/>
+              </a:solidFill>
+            </a:ln>
+          </p:spPr>
+          <p:style>
+            <a:lnRef idx="2">
+              <a:schemeClr val="accent1">
+                <a:shade val="15000"/>
+              </a:schemeClr>
+            </a:lnRef>
+            <a:fillRef idx="1">
+              <a:schemeClr val="accent1"/>
+            </a:fillRef>
+            <a:effectRef idx="0">
+              <a:schemeClr val="accent1"/>
+            </a:effectRef>
+            <a:fontRef idx="minor">
+              <a:schemeClr val="lt1"/>
+            </a:fontRef>
+          </p:style>
+          <p:txBody>
+            <a:bodyPr rtlCol="0" anchor="ctr"/>
+            <a:lstStyle/>
+            <a:p>
+              <a:pPr algn="ctr"/>
+              <a:endParaRPr lang="LID4096"/>
+            </a:p>
+          </p:txBody>
+        </p:sp>
+        <p:sp>
+          <p:nvSpPr>
+            <p:cNvPr id="29" name="TextBox 28">
+              <a:extLst>
+                <a:ext uri="{FF2B5EF4-FFF2-40B4-BE49-F238E27FC236}">
+                  <a16:creationId xmlns:a16="http://schemas.microsoft.com/office/drawing/2014/main" id="{696793E2-8D61-3261-1006-B4CECE50DB0C}"/>
+                </a:ext>
+              </a:extLst>
+            </p:cNvPr>
+            <p:cNvSpPr txBox="1"/>
+            <p:nvPr/>
+          </p:nvSpPr>
+          <p:spPr>
+            <a:xfrm>
+              <a:off x="5113249" y="1137714"/>
+              <a:ext cx="757636" cy="184666"/>
+            </a:xfrm>
+            <a:prstGeom prst="rect">
+              <a:avLst/>
+            </a:prstGeom>
+            <a:noFill/>
+          </p:spPr>
+          <p:txBody>
+            <a:bodyPr wrap="none" rtlCol="0">
+              <a:spAutoFit/>
+            </a:bodyPr>
+            <a:lstStyle/>
+            <a:p>
+              <a:pPr algn="r"/>
+              <a:r>
+                <a:rPr lang="sv-SE" sz="600">
+                  <a:solidFill>
+                    <a:srgbClr val="C00000"/>
+                  </a:solidFill>
+                </a:rPr>
+                <a:t>ökar pekaren med 4 bytes</a:t>
+              </a:r>
+              <a:endParaRPr lang="LID4096" sz="600">
+                <a:solidFill>
+                  <a:srgbClr val="C00000"/>
+                </a:solidFill>
+              </a:endParaRPr>
+            </a:p>
+          </p:txBody>
+        </p:sp>
+      </p:grpSp>
+      <p:grpSp>
+        <p:nvGrpSpPr>
+          <p:cNvPr id="30" name="Group 29">
+            <a:extLst>
+              <a:ext uri="{FF2B5EF4-FFF2-40B4-BE49-F238E27FC236}">
+                <a16:creationId xmlns:a16="http://schemas.microsoft.com/office/drawing/2014/main" id="{B05E2D5C-1406-35EC-2991-DB2033644A5D}"/>
+              </a:ext>
+            </a:extLst>
+          </p:cNvPr>
+          <p:cNvGrpSpPr/>
+          <p:nvPr/>
+        </p:nvGrpSpPr>
+        <p:grpSpPr>
+          <a:xfrm>
+            <a:off x="6772265" y="4956764"/>
+            <a:ext cx="1300356" cy="340724"/>
+            <a:chOff x="3335893" y="1042224"/>
+            <a:chExt cx="6160496" cy="315714"/>
+          </a:xfrm>
+        </p:grpSpPr>
+        <p:sp>
+          <p:nvSpPr>
+            <p:cNvPr id="31" name="Rectangle 30">
+              <a:extLst>
+                <a:ext uri="{FF2B5EF4-FFF2-40B4-BE49-F238E27FC236}">
+                  <a16:creationId xmlns:a16="http://schemas.microsoft.com/office/drawing/2014/main" id="{1F6A1A2E-645C-ADD1-39C3-52B104B1ACD6}"/>
+                </a:ext>
+              </a:extLst>
+            </p:cNvPr>
+            <p:cNvSpPr/>
+            <p:nvPr/>
+          </p:nvSpPr>
+          <p:spPr>
+            <a:xfrm>
+              <a:off x="4648477" y="1042224"/>
+              <a:ext cx="1139811" cy="144603"/>
+            </a:xfrm>
+            <a:prstGeom prst="rect">
+              <a:avLst/>
+            </a:prstGeom>
+            <a:noFill/>
+            <a:ln>
+              <a:solidFill>
+                <a:srgbClr val="C00000"/>
+              </a:solidFill>
+            </a:ln>
+          </p:spPr>
+          <p:style>
+            <a:lnRef idx="2">
+              <a:schemeClr val="accent1">
+                <a:shade val="15000"/>
+              </a:schemeClr>
+            </a:lnRef>
+            <a:fillRef idx="1">
+              <a:schemeClr val="accent1"/>
+            </a:fillRef>
+            <a:effectRef idx="0">
+              <a:schemeClr val="accent1"/>
+            </a:effectRef>
+            <a:fontRef idx="minor">
+              <a:schemeClr val="lt1"/>
+            </a:fontRef>
+          </p:style>
+          <p:txBody>
+            <a:bodyPr rtlCol="0" anchor="ctr"/>
+            <a:lstStyle/>
+            <a:p>
+              <a:pPr algn="ctr"/>
+              <a:endParaRPr lang="LID4096"/>
+            </a:p>
+          </p:txBody>
+        </p:sp>
+        <p:sp>
+          <p:nvSpPr>
+            <p:cNvPr id="32" name="TextBox 31">
+              <a:extLst>
+                <a:ext uri="{FF2B5EF4-FFF2-40B4-BE49-F238E27FC236}">
+                  <a16:creationId xmlns:a16="http://schemas.microsoft.com/office/drawing/2014/main" id="{272C0E8E-367A-994B-7F98-0A81CAC84C63}"/>
+                </a:ext>
+              </a:extLst>
+            </p:cNvPr>
+            <p:cNvSpPr txBox="1"/>
+            <p:nvPr/>
+          </p:nvSpPr>
+          <p:spPr>
+            <a:xfrm>
+              <a:off x="3335893" y="1186827"/>
+              <a:ext cx="6160496" cy="171111"/>
+            </a:xfrm>
+            <a:prstGeom prst="rect">
+              <a:avLst/>
+            </a:prstGeom>
+            <a:noFill/>
+          </p:spPr>
+          <p:txBody>
+            <a:bodyPr wrap="none" rtlCol="0">
+              <a:spAutoFit/>
+            </a:bodyPr>
+            <a:lstStyle/>
+            <a:p>
+              <a:pPr algn="r"/>
+              <a:r>
+                <a:rPr lang="sv-SE" sz="600">
+                  <a:solidFill>
+                    <a:srgbClr val="C00000"/>
+                  </a:solidFill>
+                </a:rPr>
+                <a:t>orginalvärdet kommer inte ändras</a:t>
+              </a:r>
+              <a:endParaRPr lang="LID4096" sz="600">
+                <a:solidFill>
+                  <a:srgbClr val="C00000"/>
+                </a:solidFill>
+              </a:endParaRPr>
+            </a:p>
+          </p:txBody>
+        </p:sp>
+      </p:grpSp>
+    </p:spTree>
+    <p:extLst>
+      <p:ext uri="{BB962C8B-B14F-4D97-AF65-F5344CB8AC3E}">
+        <p14:creationId xmlns:p14="http://schemas.microsoft.com/office/powerpoint/2010/main" val="2350777232"/>
+      </p:ext>
+    </p:extLst>
+  </p:cSld>
+  <p:clrMapOvr>
+    <a:masterClrMapping/>
+  </p:clrMapOvr>
+  <p:timing>
+    <p:tnLst>
+      <p:par>
+        <p:cTn id="1" dur="indefinite" restart="never" nodeType="tmRoot">
+          <p:childTnLst>
+            <p:seq concurrent="1" nextAc="seek">
+              <p:cTn id="2" dur="indefinite" nodeType="mainSeq">
+                <p:childTnLst>
+                  <p:par>
+                    <p:cTn id="3" fill="hold">
+                      <p:stCondLst>
+                        <p:cond delay="indefinite"/>
+                      </p:stCondLst>
+                      <p:childTnLst>
+                        <p:par>
+                          <p:cTn id="4" fill="hold">
+                            <p:stCondLst>
+                              <p:cond delay="0"/>
+                            </p:stCondLst>
+                            <p:childTnLst>
+                              <p:par>
+                                <p:cTn id="5" presetID="10" presetClass="entr" presetSubtype="0" fill="hold" nodeType="clickEffect">
+                                  <p:stCondLst>
+                                    <p:cond delay="0"/>
+                                  </p:stCondLst>
+                                  <p:childTnLst>
+                                    <p:set>
+                                      <p:cBhvr>
+                                        <p:cTn id="6" dur="1" fill="hold">
+                                          <p:stCondLst>
+                                            <p:cond delay="0"/>
+                                          </p:stCondLst>
+                                        </p:cTn>
+                                        <p:tgtEl>
+                                          <p:spTgt spid="8"/>
+                                        </p:tgtEl>
+                                        <p:attrNameLst>
+                                          <p:attrName>style.visibility</p:attrName>
+                                        </p:attrNameLst>
+                                      </p:cBhvr>
+                                      <p:to>
+                                        <p:strVal val="visible"/>
+                                      </p:to>
+                                    </p:set>
+                                    <p:animEffect transition="in" filter="fade">
+                                      <p:cBhvr>
+                                        <p:cTn id="7" dur="500"/>
+                                        <p:tgtEl>
+                                          <p:spTgt spid="8"/>
+                                        </p:tgtEl>
+                                      </p:cBhvr>
+                                    </p:animEffect>
+                                  </p:childTnLst>
+                                </p:cTn>
+                              </p:par>
+                            </p:childTnLst>
+                          </p:cTn>
+                        </p:par>
+                      </p:childTnLst>
+                    </p:cTn>
+                  </p:par>
+                  <p:par>
+                    <p:cTn id="8" fill="hold">
+                      <p:stCondLst>
+                        <p:cond delay="indefinite"/>
+                      </p:stCondLst>
+                      <p:childTnLst>
+                        <p:par>
+                          <p:cTn id="9" fill="hold">
+                            <p:stCondLst>
+                              <p:cond delay="0"/>
+                            </p:stCondLst>
+                            <p:childTnLst>
+                              <p:par>
+                                <p:cTn id="10" presetID="10" presetClass="entr" presetSubtype="0" fill="hold" nodeType="clickEffect">
+                                  <p:stCondLst>
+                                    <p:cond delay="0"/>
+                                  </p:stCondLst>
+                                  <p:childTnLst>
+                                    <p:set>
+                                      <p:cBhvr>
+                                        <p:cTn id="11" dur="1" fill="hold">
+                                          <p:stCondLst>
+                                            <p:cond delay="0"/>
+                                          </p:stCondLst>
+                                        </p:cTn>
+                                        <p:tgtEl>
+                                          <p:spTgt spid="11"/>
+                                        </p:tgtEl>
+                                        <p:attrNameLst>
+                                          <p:attrName>style.visibility</p:attrName>
+                                        </p:attrNameLst>
+                                      </p:cBhvr>
+                                      <p:to>
+                                        <p:strVal val="visible"/>
+                                      </p:to>
+                                    </p:set>
+                                    <p:animEffect transition="in" filter="fade">
+                                      <p:cBhvr>
+                                        <p:cTn id="12" dur="500"/>
+                                        <p:tgtEl>
+                                          <p:spTgt spid="11"/>
+                                        </p:tgtEl>
+                                      </p:cBhvr>
+                                    </p:animEffect>
+                                  </p:childTnLst>
+                                </p:cTn>
+                              </p:par>
+                            </p:childTnLst>
+                          </p:cTn>
+                        </p:par>
+                      </p:childTnLst>
+                    </p:cTn>
+                  </p:par>
+                  <p:par>
+                    <p:cTn id="13" fill="hold">
+                      <p:stCondLst>
+                        <p:cond delay="indefinite"/>
+                      </p:stCondLst>
+                      <p:childTnLst>
+                        <p:par>
+                          <p:cTn id="14" fill="hold">
+                            <p:stCondLst>
+                              <p:cond delay="0"/>
+                            </p:stCondLst>
+                            <p:childTnLst>
+                              <p:par>
+                                <p:cTn id="15" presetID="10" presetClass="entr" presetSubtype="0" fill="hold" nodeType="clickEffect">
+                                  <p:stCondLst>
+                                    <p:cond delay="0"/>
+                                  </p:stCondLst>
+                                  <p:childTnLst>
+                                    <p:set>
+                                      <p:cBhvr>
+                                        <p:cTn id="16" dur="1" fill="hold">
+                                          <p:stCondLst>
+                                            <p:cond delay="0"/>
+                                          </p:stCondLst>
+                                        </p:cTn>
+                                        <p:tgtEl>
+                                          <p:spTgt spid="14"/>
+                                        </p:tgtEl>
+                                        <p:attrNameLst>
+                                          <p:attrName>style.visibility</p:attrName>
+                                        </p:attrNameLst>
+                                      </p:cBhvr>
+                                      <p:to>
+                                        <p:strVal val="visible"/>
+                                      </p:to>
+                                    </p:set>
+                                    <p:animEffect transition="in" filter="fade">
+                                      <p:cBhvr>
+                                        <p:cTn id="17" dur="500"/>
+                                        <p:tgtEl>
+                                          <p:spTgt spid="14"/>
+                                        </p:tgtEl>
+                                      </p:cBhvr>
+                                    </p:animEffect>
+                                  </p:childTnLst>
+                                </p:cTn>
+                              </p:par>
+                            </p:childTnLst>
+                          </p:cTn>
+                        </p:par>
+                      </p:childTnLst>
+                    </p:cTn>
+                  </p:par>
+                  <p:par>
+                    <p:cTn id="18" fill="hold">
+                      <p:stCondLst>
+                        <p:cond delay="indefinite"/>
+                      </p:stCondLst>
+                      <p:childTnLst>
+                        <p:par>
+                          <p:cTn id="19" fill="hold">
+                            <p:stCondLst>
+                              <p:cond delay="0"/>
+                            </p:stCondLst>
+                            <p:childTnLst>
+                              <p:par>
+                                <p:cTn id="20" presetID="10" presetClass="entr" presetSubtype="0" fill="hold" nodeType="clickEffect">
+                                  <p:stCondLst>
+                                    <p:cond delay="0"/>
+                                  </p:stCondLst>
+                                  <p:childTnLst>
+                                    <p:set>
+                                      <p:cBhvr>
+                                        <p:cTn id="21" dur="1" fill="hold">
+                                          <p:stCondLst>
+                                            <p:cond delay="0"/>
+                                          </p:stCondLst>
+                                        </p:cTn>
+                                        <p:tgtEl>
+                                          <p:spTgt spid="18"/>
+                                        </p:tgtEl>
+                                        <p:attrNameLst>
+                                          <p:attrName>style.visibility</p:attrName>
+                                        </p:attrNameLst>
+                                      </p:cBhvr>
+                                      <p:to>
+                                        <p:strVal val="visible"/>
+                                      </p:to>
+                                    </p:set>
+                                    <p:animEffect transition="in" filter="fade">
+                                      <p:cBhvr>
+                                        <p:cTn id="22" dur="500"/>
+                                        <p:tgtEl>
+                                          <p:spTgt spid="18"/>
+                                        </p:tgtEl>
+                                      </p:cBhvr>
+                                    </p:animEffect>
+                                  </p:childTnLst>
+                                </p:cTn>
+                              </p:par>
+                            </p:childTnLst>
+                          </p:cTn>
+                        </p:par>
+                      </p:childTnLst>
+                    </p:cTn>
+                  </p:par>
+                  <p:par>
+                    <p:cTn id="23" fill="hold">
+                      <p:stCondLst>
+                        <p:cond delay="indefinite"/>
+                      </p:stCondLst>
+                      <p:childTnLst>
+                        <p:par>
+                          <p:cTn id="24" fill="hold">
+                            <p:stCondLst>
+                              <p:cond delay="0"/>
+                            </p:stCondLst>
+                            <p:childTnLst>
+                              <p:par>
+                                <p:cTn id="25" presetID="10" presetClass="entr" presetSubtype="0" fill="hold" nodeType="clickEffect">
+                                  <p:stCondLst>
+                                    <p:cond delay="0"/>
+                                  </p:stCondLst>
+                                  <p:childTnLst>
+                                    <p:set>
+                                      <p:cBhvr>
+                                        <p:cTn id="26" dur="1" fill="hold">
+                                          <p:stCondLst>
+                                            <p:cond delay="0"/>
+                                          </p:stCondLst>
+                                        </p:cTn>
+                                        <p:tgtEl>
+                                          <p:spTgt spid="24"/>
+                                        </p:tgtEl>
+                                        <p:attrNameLst>
+                                          <p:attrName>style.visibility</p:attrName>
+                                        </p:attrNameLst>
+                                      </p:cBhvr>
+                                      <p:to>
+                                        <p:strVal val="visible"/>
+                                      </p:to>
+                                    </p:set>
+                                    <p:animEffect transition="in" filter="fade">
+                                      <p:cBhvr>
+                                        <p:cTn id="27" dur="500"/>
+                                        <p:tgtEl>
+                                          <p:spTgt spid="24"/>
+                                        </p:tgtEl>
+                                      </p:cBhvr>
+                                    </p:animEffect>
+                                  </p:childTnLst>
+                                </p:cTn>
+                              </p:par>
+                            </p:childTnLst>
+                          </p:cTn>
+                        </p:par>
+                      </p:childTnLst>
+                    </p:cTn>
+                  </p:par>
+                  <p:par>
+                    <p:cTn id="28" fill="hold">
+                      <p:stCondLst>
+                        <p:cond delay="indefinite"/>
+                      </p:stCondLst>
+                      <p:childTnLst>
+                        <p:par>
+                          <p:cTn id="29" fill="hold">
+                            <p:stCondLst>
+                              <p:cond delay="0"/>
+                            </p:stCondLst>
+                            <p:childTnLst>
+                              <p:par>
+                                <p:cTn id="30" presetID="10" presetClass="entr" presetSubtype="0" fill="hold" nodeType="clickEffect">
+                                  <p:stCondLst>
+                                    <p:cond delay="0"/>
+                                  </p:stCondLst>
+                                  <p:childTnLst>
+                                    <p:set>
+                                      <p:cBhvr>
+                                        <p:cTn id="31" dur="1" fill="hold">
+                                          <p:stCondLst>
+                                            <p:cond delay="0"/>
+                                          </p:stCondLst>
+                                        </p:cTn>
+                                        <p:tgtEl>
+                                          <p:spTgt spid="27"/>
+                                        </p:tgtEl>
+                                        <p:attrNameLst>
+                                          <p:attrName>style.visibility</p:attrName>
+                                        </p:attrNameLst>
+                                      </p:cBhvr>
+                                      <p:to>
+                                        <p:strVal val="visible"/>
+                                      </p:to>
+                                    </p:set>
+                                    <p:animEffect transition="in" filter="fade">
+                                      <p:cBhvr>
+                                        <p:cTn id="32" dur="500"/>
+                                        <p:tgtEl>
+                                          <p:spTgt spid="27"/>
+                                        </p:tgtEl>
+                                      </p:cBhvr>
+                                    </p:animEffect>
+                                  </p:childTnLst>
+                                </p:cTn>
+                              </p:par>
+                            </p:childTnLst>
+                          </p:cTn>
+                        </p:par>
+                      </p:childTnLst>
+                    </p:cTn>
+                  </p:par>
+                  <p:par>
+                    <p:cTn id="33" fill="hold">
+                      <p:stCondLst>
+                        <p:cond delay="indefinite"/>
+                      </p:stCondLst>
+                      <p:childTnLst>
+                        <p:par>
+                          <p:cTn id="34" fill="hold">
+                            <p:stCondLst>
+                              <p:cond delay="0"/>
+                            </p:stCondLst>
+                            <p:childTnLst>
+                              <p:par>
+                                <p:cTn id="35" presetID="10" presetClass="entr" presetSubtype="0" fill="hold" nodeType="clickEffect">
+                                  <p:stCondLst>
+                                    <p:cond delay="0"/>
+                                  </p:stCondLst>
+                                  <p:childTnLst>
+                                    <p:set>
+                                      <p:cBhvr>
+                                        <p:cTn id="36" dur="1" fill="hold">
+                                          <p:stCondLst>
+                                            <p:cond delay="0"/>
+                                          </p:stCondLst>
+                                        </p:cTn>
+                                        <p:tgtEl>
+                                          <p:spTgt spid="30"/>
+                                        </p:tgtEl>
+                                        <p:attrNameLst>
+                                          <p:attrName>style.visibility</p:attrName>
+                                        </p:attrNameLst>
+                                      </p:cBhvr>
+                                      <p:to>
+                                        <p:strVal val="visible"/>
+                                      </p:to>
+                                    </p:set>
+                                    <p:animEffect transition="in" filter="fade">
+                                      <p:cBhvr>
+                                        <p:cTn id="37" dur="500"/>
+                                        <p:tgtEl>
+                                          <p:spTgt spid="30"/>
+                                        </p:tgtEl>
+                                      </p:cBhvr>
+                                    </p:animEffect>
+                                  </p:childTnLst>
+                                </p:cTn>
+                              </p:par>
+                            </p:childTnLst>
+                          </p:cTn>
+                        </p:par>
+                      </p:childTnLst>
+                    </p:cTn>
+                  </p:par>
+                </p:childTnLst>
+              </p:cTn>
+              <p:prevCondLst>
+                <p:cond evt="onPrev" delay="0">
+                  <p:tgtEl>
+                    <p:sldTgt/>
+                  </p:tgtEl>
+                </p:cond>
+              </p:prevCondLst>
+              <p:nextCondLst>
+                <p:cond evt="onNext" delay="0">
+                  <p:tgtEl>
+                    <p:sldTgt/>
+                  </p:tgtEl>
+                </p:cond>
+              </p:nextCondLst>
+            </p:seq>
+          </p:childTnLst>
+        </p:cTn>
+      </p:par>
+    </p:tnLst>
+  </p:timing>
+</p:sld>
+</file>
+
 <file path=ppt/theme/theme1.xml><?xml version="1.0" encoding="utf-8"?>
 <a:theme xmlns:a="http://schemas.openxmlformats.org/drawingml/2006/main" name="Office Theme">
   <a:themeElements>

</xml_diff>